<commit_message>
Add BOM and expand README (differential)
Add a new BOM (BOM/bom_rover.csv) listing components and quantities. Update README with a real differential (balancín + bieletas), expanded parts/specs (chassis size, estimated mass bumped to ~30 kg), detailed parts table, filament estimates, and printing notes (ball-joints on bieletas, 5 mm joint walls). Also updates mobility/steering details and small copy edits. A PowerPoint in Journal was modified (binary change).
</commit_message>
<xml_diff>
--- a/Journal/Librito_Rover x_x (CreacionSistemaMecanico) .pptx
+++ b/Journal/Librito_Rover x_x (CreacionSistemaMecanico) .pptx
@@ -124,6 +124,266 @@
     </p:ext>
   </p:extLst>
 </p:presentation>
+</file>
+
+<file path=ppt/changesInfos/changesInfo1.xml><?xml version="1.0" encoding="utf-8"?>
+<pc:chgInfo xmlns:a="http://schemas.openxmlformats.org/drawingml/2006/main" xmlns:r="http://schemas.openxmlformats.org/officeDocument/2006/relationships" xmlns:ac="http://schemas.microsoft.com/office/drawing/2013/main/command" xmlns:pc="http://schemas.microsoft.com/office/powerpoint/2013/main/command">
+  <pc:docChgLst>
+    <pc:chgData name="Sebastian Ortiz" userId="773f68a2549011c7" providerId="LiveId" clId="{76860DA8-2F0E-4920-88CB-81A8E296120B}"/>
+    <pc:docChg chg="custSel modSld">
+      <pc:chgData name="Sebastian Ortiz" userId="773f68a2549011c7" providerId="LiveId" clId="{76860DA8-2F0E-4920-88CB-81A8E296120B}" dt="2026-07-01T23:00:27.096" v="45" actId="478"/>
+      <pc:docMkLst>
+        <pc:docMk/>
+      </pc:docMkLst>
+      <pc:sldChg chg="modSp mod">
+        <pc:chgData name="Sebastian Ortiz" userId="773f68a2549011c7" providerId="LiveId" clId="{76860DA8-2F0E-4920-88CB-81A8E296120B}" dt="2026-07-01T22:47:29.745" v="1" actId="1076"/>
+        <pc:sldMkLst>
+          <pc:docMk/>
+          <pc:sldMk cId="0" sldId="256"/>
+        </pc:sldMkLst>
+        <pc:picChg chg="mod">
+          <ac:chgData name="Sebastian Ortiz" userId="773f68a2549011c7" providerId="LiveId" clId="{76860DA8-2F0E-4920-88CB-81A8E296120B}" dt="2026-07-01T22:47:29.745" v="1" actId="1076"/>
+          <ac:picMkLst>
+            <pc:docMk/>
+            <pc:sldMk cId="0" sldId="256"/>
+            <ac:picMk id="2" creationId="{00000000-0000-0000-0000-000000000000}"/>
+          </ac:picMkLst>
+        </pc:picChg>
+      </pc:sldChg>
+      <pc:sldChg chg="delSp modSp mod">
+        <pc:chgData name="Sebastian Ortiz" userId="773f68a2549011c7" providerId="LiveId" clId="{76860DA8-2F0E-4920-88CB-81A8E296120B}" dt="2026-07-01T22:52:27.964" v="4" actId="478"/>
+        <pc:sldMkLst>
+          <pc:docMk/>
+          <pc:sldMk cId="0" sldId="259"/>
+        </pc:sldMkLst>
+        <pc:spChg chg="del">
+          <ac:chgData name="Sebastian Ortiz" userId="773f68a2549011c7" providerId="LiveId" clId="{76860DA8-2F0E-4920-88CB-81A8E296120B}" dt="2026-07-01T22:52:24.246" v="2" actId="478"/>
+          <ac:spMkLst>
+            <pc:docMk/>
+            <pc:sldMk cId="0" sldId="259"/>
+            <ac:spMk id="10" creationId="{00000000-0000-0000-0000-000000000000}"/>
+          </ac:spMkLst>
+        </pc:spChg>
+        <pc:spChg chg="del mod">
+          <ac:chgData name="Sebastian Ortiz" userId="773f68a2549011c7" providerId="LiveId" clId="{76860DA8-2F0E-4920-88CB-81A8E296120B}" dt="2026-07-01T22:52:27.964" v="4" actId="478"/>
+          <ac:spMkLst>
+            <pc:docMk/>
+            <pc:sldMk cId="0" sldId="259"/>
+            <ac:spMk id="11" creationId="{00000000-0000-0000-0000-000000000000}"/>
+          </ac:spMkLst>
+        </pc:spChg>
+      </pc:sldChg>
+      <pc:sldChg chg="delSp modSp mod">
+        <pc:chgData name="Sebastian Ortiz" userId="773f68a2549011c7" providerId="LiveId" clId="{76860DA8-2F0E-4920-88CB-81A8E296120B}" dt="2026-07-01T22:53:33.950" v="7" actId="478"/>
+        <pc:sldMkLst>
+          <pc:docMk/>
+          <pc:sldMk cId="0" sldId="260"/>
+        </pc:sldMkLst>
+        <pc:spChg chg="del mod">
+          <ac:chgData name="Sebastian Ortiz" userId="773f68a2549011c7" providerId="LiveId" clId="{76860DA8-2F0E-4920-88CB-81A8E296120B}" dt="2026-07-01T22:53:31.878" v="6" actId="478"/>
+          <ac:spMkLst>
+            <pc:docMk/>
+            <pc:sldMk cId="0" sldId="260"/>
+            <ac:spMk id="12" creationId="{00000000-0000-0000-0000-000000000000}"/>
+          </ac:spMkLst>
+        </pc:spChg>
+        <pc:spChg chg="del">
+          <ac:chgData name="Sebastian Ortiz" userId="773f68a2549011c7" providerId="LiveId" clId="{76860DA8-2F0E-4920-88CB-81A8E296120B}" dt="2026-07-01T22:53:33.950" v="7" actId="478"/>
+          <ac:spMkLst>
+            <pc:docMk/>
+            <pc:sldMk cId="0" sldId="260"/>
+            <ac:spMk id="13" creationId="{00000000-0000-0000-0000-000000000000}"/>
+          </ac:spMkLst>
+        </pc:spChg>
+      </pc:sldChg>
+      <pc:sldChg chg="addSp modSp mod">
+        <pc:chgData name="Sebastian Ortiz" userId="773f68a2549011c7" providerId="LiveId" clId="{76860DA8-2F0E-4920-88CB-81A8E296120B}" dt="2026-07-01T22:55:43.992" v="11" actId="14100"/>
+        <pc:sldMkLst>
+          <pc:docMk/>
+          <pc:sldMk cId="0" sldId="261"/>
+        </pc:sldMkLst>
+        <pc:picChg chg="add mod">
+          <ac:chgData name="Sebastian Ortiz" userId="773f68a2549011c7" providerId="LiveId" clId="{76860DA8-2F0E-4920-88CB-81A8E296120B}" dt="2026-07-01T22:55:43.992" v="11" actId="14100"/>
+          <ac:picMkLst>
+            <pc:docMk/>
+            <pc:sldMk cId="0" sldId="261"/>
+            <ac:picMk id="23" creationId="{D8680344-AB4D-812B-610A-1FE22BA92EB2}"/>
+          </ac:picMkLst>
+        </pc:picChg>
+      </pc:sldChg>
+      <pc:sldChg chg="delSp modSp mod">
+        <pc:chgData name="Sebastian Ortiz" userId="773f68a2549011c7" providerId="LiveId" clId="{76860DA8-2F0E-4920-88CB-81A8E296120B}" dt="2026-07-01T22:57:07.860" v="14" actId="478"/>
+        <pc:sldMkLst>
+          <pc:docMk/>
+          <pc:sldMk cId="0" sldId="262"/>
+        </pc:sldMkLst>
+        <pc:spChg chg="del">
+          <ac:chgData name="Sebastian Ortiz" userId="773f68a2549011c7" providerId="LiveId" clId="{76860DA8-2F0E-4920-88CB-81A8E296120B}" dt="2026-07-01T22:57:02.727" v="12" actId="478"/>
+          <ac:spMkLst>
+            <pc:docMk/>
+            <pc:sldMk cId="0" sldId="262"/>
+            <ac:spMk id="13" creationId="{00000000-0000-0000-0000-000000000000}"/>
+          </ac:spMkLst>
+        </pc:spChg>
+        <pc:spChg chg="del mod">
+          <ac:chgData name="Sebastian Ortiz" userId="773f68a2549011c7" providerId="LiveId" clId="{76860DA8-2F0E-4920-88CB-81A8E296120B}" dt="2026-07-01T22:57:07.860" v="14" actId="478"/>
+          <ac:spMkLst>
+            <pc:docMk/>
+            <pc:sldMk cId="0" sldId="262"/>
+            <ac:spMk id="14" creationId="{00000000-0000-0000-0000-000000000000}"/>
+          </ac:spMkLst>
+        </pc:spChg>
+      </pc:sldChg>
+      <pc:sldChg chg="delSp mod">
+        <pc:chgData name="Sebastian Ortiz" userId="773f68a2549011c7" providerId="LiveId" clId="{76860DA8-2F0E-4920-88CB-81A8E296120B}" dt="2026-07-01T22:58:02.201" v="16" actId="478"/>
+        <pc:sldMkLst>
+          <pc:docMk/>
+          <pc:sldMk cId="0" sldId="264"/>
+        </pc:sldMkLst>
+        <pc:spChg chg="del">
+          <ac:chgData name="Sebastian Ortiz" userId="773f68a2549011c7" providerId="LiveId" clId="{76860DA8-2F0E-4920-88CB-81A8E296120B}" dt="2026-07-01T22:57:58.280" v="15" actId="478"/>
+          <ac:spMkLst>
+            <pc:docMk/>
+            <pc:sldMk cId="0" sldId="264"/>
+            <ac:spMk id="12" creationId="{00000000-0000-0000-0000-000000000000}"/>
+          </ac:spMkLst>
+        </pc:spChg>
+        <pc:spChg chg="del">
+          <ac:chgData name="Sebastian Ortiz" userId="773f68a2549011c7" providerId="LiveId" clId="{76860DA8-2F0E-4920-88CB-81A8E296120B}" dt="2026-07-01T22:58:02.201" v="16" actId="478"/>
+          <ac:spMkLst>
+            <pc:docMk/>
+            <pc:sldMk cId="0" sldId="264"/>
+            <ac:spMk id="13" creationId="{00000000-0000-0000-0000-000000000000}"/>
+          </ac:spMkLst>
+        </pc:spChg>
+      </pc:sldChg>
+      <pc:sldChg chg="addSp delSp modSp mod">
+        <pc:chgData name="Sebastian Ortiz" userId="773f68a2549011c7" providerId="LiveId" clId="{76860DA8-2F0E-4920-88CB-81A8E296120B}" dt="2026-07-01T22:58:38.344" v="29" actId="1076"/>
+        <pc:sldMkLst>
+          <pc:docMk/>
+          <pc:sldMk cId="0" sldId="265"/>
+        </pc:sldMkLst>
+        <pc:spChg chg="del">
+          <ac:chgData name="Sebastian Ortiz" userId="773f68a2549011c7" providerId="LiveId" clId="{76860DA8-2F0E-4920-88CB-81A8E296120B}" dt="2026-07-01T22:58:37.441" v="28" actId="478"/>
+          <ac:spMkLst>
+            <pc:docMk/>
+            <pc:sldMk cId="0" sldId="265"/>
+            <ac:spMk id="4" creationId="{00000000-0000-0000-0000-000000000000}"/>
+          </ac:spMkLst>
+        </pc:spChg>
+        <pc:spChg chg="mod">
+          <ac:chgData name="Sebastian Ortiz" userId="773f68a2549011c7" providerId="LiveId" clId="{76860DA8-2F0E-4920-88CB-81A8E296120B}" dt="2026-07-01T22:58:09.386" v="17" actId="6549"/>
+          <ac:spMkLst>
+            <pc:docMk/>
+            <pc:sldMk cId="0" sldId="265"/>
+            <ac:spMk id="12" creationId="{00000000-0000-0000-0000-000000000000}"/>
+          </ac:spMkLst>
+        </pc:spChg>
+        <pc:picChg chg="add mod">
+          <ac:chgData name="Sebastian Ortiz" userId="773f68a2549011c7" providerId="LiveId" clId="{76860DA8-2F0E-4920-88CB-81A8E296120B}" dt="2026-07-01T22:58:38.344" v="29" actId="1076"/>
+          <ac:picMkLst>
+            <pc:docMk/>
+            <pc:sldMk cId="0" sldId="265"/>
+            <ac:picMk id="19" creationId="{1F536A46-ACC4-913F-197B-75A82C7CFF08}"/>
+          </ac:picMkLst>
+        </pc:picChg>
+      </pc:sldChg>
+      <pc:sldChg chg="addSp delSp modSp mod">
+        <pc:chgData name="Sebastian Ortiz" userId="773f68a2549011c7" providerId="LiveId" clId="{76860DA8-2F0E-4920-88CB-81A8E296120B}" dt="2026-07-01T23:00:27.096" v="45" actId="478"/>
+        <pc:sldMkLst>
+          <pc:docMk/>
+          <pc:sldMk cId="0" sldId="266"/>
+        </pc:sldMkLst>
+        <pc:spChg chg="del">
+          <ac:chgData name="Sebastian Ortiz" userId="773f68a2549011c7" providerId="LiveId" clId="{76860DA8-2F0E-4920-88CB-81A8E296120B}" dt="2026-07-01T23:00:24.664" v="44" actId="478"/>
+          <ac:spMkLst>
+            <pc:docMk/>
+            <pc:sldMk cId="0" sldId="266"/>
+            <ac:spMk id="8" creationId="{00000000-0000-0000-0000-000000000000}"/>
+          </ac:spMkLst>
+        </pc:spChg>
+        <pc:spChg chg="del">
+          <ac:chgData name="Sebastian Ortiz" userId="773f68a2549011c7" providerId="LiveId" clId="{76860DA8-2F0E-4920-88CB-81A8E296120B}" dt="2026-07-01T23:00:27.096" v="45" actId="478"/>
+          <ac:spMkLst>
+            <pc:docMk/>
+            <pc:sldMk cId="0" sldId="266"/>
+            <ac:spMk id="9" creationId="{00000000-0000-0000-0000-000000000000}"/>
+          </ac:spMkLst>
+        </pc:spChg>
+        <pc:spChg chg="del">
+          <ac:chgData name="Sebastian Ortiz" userId="773f68a2549011c7" providerId="LiveId" clId="{76860DA8-2F0E-4920-88CB-81A8E296120B}" dt="2026-07-01T22:59:05.122" v="32" actId="478"/>
+          <ac:spMkLst>
+            <pc:docMk/>
+            <pc:sldMk cId="0" sldId="266"/>
+            <ac:spMk id="14" creationId="{00000000-0000-0000-0000-000000000000}"/>
+          </ac:spMkLst>
+        </pc:spChg>
+        <pc:spChg chg="del mod">
+          <ac:chgData name="Sebastian Ortiz" userId="773f68a2549011c7" providerId="LiveId" clId="{76860DA8-2F0E-4920-88CB-81A8E296120B}" dt="2026-07-01T22:59:04.345" v="31" actId="478"/>
+          <ac:spMkLst>
+            <pc:docMk/>
+            <pc:sldMk cId="0" sldId="266"/>
+            <ac:spMk id="15" creationId="{00000000-0000-0000-0000-000000000000}"/>
+          </ac:spMkLst>
+        </pc:spChg>
+        <pc:picChg chg="add mod">
+          <ac:chgData name="Sebastian Ortiz" userId="773f68a2549011c7" providerId="LiveId" clId="{76860DA8-2F0E-4920-88CB-81A8E296120B}" dt="2026-07-01T23:00:23.254" v="43" actId="1076"/>
+          <ac:picMkLst>
+            <pc:docMk/>
+            <pc:sldMk cId="0" sldId="266"/>
+            <ac:picMk id="22" creationId="{B63E306E-06AF-882B-3B33-9901092457C8}"/>
+          </ac:picMkLst>
+        </pc:picChg>
+      </pc:sldChg>
+      <pc:sldChg chg="delSp modSp mod">
+        <pc:chgData name="Sebastian Ortiz" userId="773f68a2549011c7" providerId="LiveId" clId="{76860DA8-2F0E-4920-88CB-81A8E296120B}" dt="2026-07-01T22:59:14.080" v="35" actId="478"/>
+        <pc:sldMkLst>
+          <pc:docMk/>
+          <pc:sldMk cId="0" sldId="267"/>
+        </pc:sldMkLst>
+        <pc:spChg chg="del mod">
+          <ac:chgData name="Sebastian Ortiz" userId="773f68a2549011c7" providerId="LiveId" clId="{76860DA8-2F0E-4920-88CB-81A8E296120B}" dt="2026-07-01T22:59:14.080" v="35" actId="478"/>
+          <ac:spMkLst>
+            <pc:docMk/>
+            <pc:sldMk cId="0" sldId="267"/>
+            <ac:spMk id="7" creationId="{00000000-0000-0000-0000-000000000000}"/>
+          </ac:spMkLst>
+        </pc:spChg>
+        <pc:spChg chg="del">
+          <ac:chgData name="Sebastian Ortiz" userId="773f68a2549011c7" providerId="LiveId" clId="{76860DA8-2F0E-4920-88CB-81A8E296120B}" dt="2026-07-01T22:59:08.810" v="33" actId="478"/>
+          <ac:spMkLst>
+            <pc:docMk/>
+            <pc:sldMk cId="0" sldId="267"/>
+            <ac:spMk id="12" creationId="{00000000-0000-0000-0000-000000000000}"/>
+          </ac:spMkLst>
+        </pc:spChg>
+      </pc:sldChg>
+      <pc:sldChg chg="delSp modSp mod">
+        <pc:chgData name="Sebastian Ortiz" userId="773f68a2549011c7" providerId="LiveId" clId="{76860DA8-2F0E-4920-88CB-81A8E296120B}" dt="2026-07-01T22:59:27.117" v="38" actId="478"/>
+        <pc:sldMkLst>
+          <pc:docMk/>
+          <pc:sldMk cId="0" sldId="269"/>
+        </pc:sldMkLst>
+        <pc:spChg chg="del">
+          <ac:chgData name="Sebastian Ortiz" userId="773f68a2549011c7" providerId="LiveId" clId="{76860DA8-2F0E-4920-88CB-81A8E296120B}" dt="2026-07-01T22:59:23.510" v="36" actId="478"/>
+          <ac:spMkLst>
+            <pc:docMk/>
+            <pc:sldMk cId="0" sldId="269"/>
+            <ac:spMk id="10" creationId="{00000000-0000-0000-0000-000000000000}"/>
+          </ac:spMkLst>
+        </pc:spChg>
+        <pc:spChg chg="del mod">
+          <ac:chgData name="Sebastian Ortiz" userId="773f68a2549011c7" providerId="LiveId" clId="{76860DA8-2F0E-4920-88CB-81A8E296120B}" dt="2026-07-01T22:59:27.117" v="38" actId="478"/>
+          <ac:spMkLst>
+            <pc:docMk/>
+            <pc:sldMk cId="0" sldId="269"/>
+            <ac:spMk id="11" creationId="{00000000-0000-0000-0000-000000000000}"/>
+          </ac:spMkLst>
+        </pc:spChg>
+      </pc:sldChg>
+    </pc:docChg>
+  </pc:docChgLst>
+</pc:chgInfo>
 </file>
 
 <file path=ppt/notesMasters/notesMaster1.xml><?xml version="1.0" encoding="utf-8"?>
@@ -1864,7 +2124,7 @@
         </p:blipFill>
         <p:spPr>
           <a:xfrm>
-            <a:off x="0" y="0"/>
+            <a:off x="-749300" y="-444500"/>
             <a:ext cx="7772400" cy="10058400"/>
           </a:xfrm>
           <a:prstGeom prst="rect">
@@ -3634,38 +3894,6 @@
       </p:sp>
       <p:sp>
         <p:nvSpPr>
-          <p:cNvPr id="4" name="Shape 8"/>
-          <p:cNvSpPr/>
-          <p:nvPr/>
-        </p:nvSpPr>
-        <p:spPr>
-          <a:xfrm>
-            <a:off x="457200" y="7818120"/>
-            <a:ext cx="6858000" cy="1417320"/>
-          </a:xfrm>
-          <a:prstGeom prst="rect">
-            <a:avLst/>
-          </a:prstGeom>
-          <a:solidFill>
-            <a:srgbClr val="F4F4F0"/>
-          </a:solidFill>
-          <a:ln w="12700">
-            <a:solidFill>
-              <a:srgbClr val="999999"/>
-            </a:solidFill>
-            <a:prstDash val="dash"/>
-          </a:ln>
-        </p:spPr>
-        <p:txBody>
-          <a:bodyPr/>
-          <a:lstStyle/>
-          <a:p>
-            <a:endParaRPr lang="es-CO"/>
-          </a:p>
-        </p:txBody>
-      </p:sp>
-      <p:sp>
-        <p:nvSpPr>
           <p:cNvPr id="12" name="Text 9"/>
           <p:cNvSpPr/>
           <p:nvPr/>
@@ -3688,17 +3916,6 @@
             <a:pPr marL="0" indent="0" algn="ctr">
               <a:buNone/>
             </a:pPr>
-            <a:r>
-              <a:rPr lang="en-US" sz="1100" i="1" dirty="0">
-                <a:solidFill>
-                  <a:srgbClr val="888888"/>
-                </a:solidFill>
-                <a:latin typeface="Calibri" pitchFamily="34" charset="0"/>
-                <a:ea typeface="Calibri" pitchFamily="34" charset="-122"/>
-                <a:cs typeface="Calibri" pitchFamily="34" charset="-120"/>
-              </a:rPr>
-              <a:t>[ Fusion screenshot: the balancin + bieletas linkage ]</a:t>
-            </a:r>
             <a:endParaRPr lang="en-US" sz="1100" dirty="0"/>
           </a:p>
         </p:txBody>
@@ -3922,6 +4139,36 @@
           </a:p>
         </p:txBody>
       </p:sp>
+      <p:pic>
+        <p:nvPicPr>
+          <p:cNvPr id="19" name="Imagen 18">
+            <a:extLst>
+              <a:ext uri="{FF2B5EF4-FFF2-40B4-BE49-F238E27FC236}">
+                <a16:creationId xmlns:a16="http://schemas.microsoft.com/office/drawing/2014/main" id="{1F536A46-ACC4-913F-197B-75A82C7CFF08}"/>
+              </a:ext>
+            </a:extLst>
+          </p:cNvPr>
+          <p:cNvPicPr>
+            <a:picLocks noChangeAspect="1"/>
+          </p:cNvPicPr>
+          <p:nvPr/>
+        </p:nvPicPr>
+        <p:blipFill>
+          <a:blip r:embed="rId3"/>
+          <a:stretch>
+            <a:fillRect/>
+          </a:stretch>
+        </p:blipFill>
+        <p:spPr>
+          <a:xfrm>
+            <a:off x="1743075" y="7754112"/>
+            <a:ext cx="4392930" cy="1540226"/>
+          </a:xfrm>
+          <a:prstGeom prst="rect">
+            <a:avLst/>
+          </a:prstGeom>
+        </p:spPr>
+      </p:pic>
     </p:spTree>
   </p:cSld>
   <p:clrMapOvr>
@@ -5271,77 +5518,6 @@
       </p:graphicFrame>
       <p:sp>
         <p:nvSpPr>
-          <p:cNvPr id="8" name="Shape 5"/>
-          <p:cNvSpPr/>
-          <p:nvPr/>
-        </p:nvSpPr>
-        <p:spPr>
-          <a:xfrm>
-            <a:off x="5212080" y="2743200"/>
-            <a:ext cx="2103120" cy="1645920"/>
-          </a:xfrm>
-          <a:prstGeom prst="rect">
-            <a:avLst/>
-          </a:prstGeom>
-          <a:solidFill>
-            <a:srgbClr val="F4F4F0"/>
-          </a:solidFill>
-          <a:ln w="12700">
-            <a:solidFill>
-              <a:srgbClr val="999999"/>
-            </a:solidFill>
-            <a:prstDash val="dash"/>
-          </a:ln>
-        </p:spPr>
-        <p:txBody>
-          <a:bodyPr/>
-          <a:lstStyle/>
-          <a:p>
-            <a:endParaRPr lang="es-CO"/>
-          </a:p>
-        </p:txBody>
-      </p:sp>
-      <p:sp>
-        <p:nvSpPr>
-          <p:cNvPr id="9" name="Text 6"/>
-          <p:cNvSpPr/>
-          <p:nvPr/>
-        </p:nvSpPr>
-        <p:spPr>
-          <a:xfrm>
-            <a:off x="5303520" y="2743200"/>
-            <a:ext cx="1920240" cy="1645920"/>
-          </a:xfrm>
-          <a:prstGeom prst="rect">
-            <a:avLst/>
-          </a:prstGeom>
-          <a:noFill/>
-          <a:ln/>
-        </p:spPr>
-        <p:txBody>
-          <a:bodyPr wrap="square" rtlCol="0" anchor="ctr"/>
-          <a:lstStyle/>
-          <a:p>
-            <a:pPr marL="0" indent="0" algn="ctr">
-              <a:buNone/>
-            </a:pPr>
-            <a:r>
-              <a:rPr lang="en-US" sz="1100" i="1" dirty="0">
-                <a:solidFill>
-                  <a:srgbClr val="888888"/>
-                </a:solidFill>
-                <a:latin typeface="Calibri" pitchFamily="34" charset="0"/>
-                <a:ea typeface="Calibri" pitchFamily="34" charset="-122"/>
-                <a:cs typeface="Calibri" pitchFamily="34" charset="-120"/>
-              </a:rPr>
-              <a:t>[ sketch: C-mount w/ servo ]</a:t>
-            </a:r>
-            <a:endParaRPr lang="en-US" sz="1100" dirty="0"/>
-          </a:p>
-        </p:txBody>
-      </p:sp>
-      <p:sp>
-        <p:nvSpPr>
           <p:cNvPr id="10" name="Text 7"/>
           <p:cNvSpPr/>
           <p:nvPr/>
@@ -5503,77 +5679,6 @@
               <a:t>Instead of measuring angles off the tube, I just orient each socket so the mount hangs plumb (checked with a level) when the rover sits flat. Then the servo axis is vertical automatically. I'll design the mounts with slotted holes so final leveling is a slide-and-tighten on a flat surface.</a:t>
             </a:r>
             <a:endParaRPr lang="en-US" sz="1000" dirty="0"/>
-          </a:p>
-        </p:txBody>
-      </p:sp>
-      <p:sp>
-        <p:nvSpPr>
-          <p:cNvPr id="14" name="Shape 11"/>
-          <p:cNvSpPr/>
-          <p:nvPr/>
-        </p:nvSpPr>
-        <p:spPr>
-          <a:xfrm>
-            <a:off x="457200" y="7315200"/>
-            <a:ext cx="6858000" cy="1920240"/>
-          </a:xfrm>
-          <a:prstGeom prst="rect">
-            <a:avLst/>
-          </a:prstGeom>
-          <a:solidFill>
-            <a:srgbClr val="F4F4F0"/>
-          </a:solidFill>
-          <a:ln w="12700">
-            <a:solidFill>
-              <a:srgbClr val="999999"/>
-            </a:solidFill>
-            <a:prstDash val="dash"/>
-          </a:ln>
-        </p:spPr>
-        <p:txBody>
-          <a:bodyPr/>
-          <a:lstStyle/>
-          <a:p>
-            <a:endParaRPr lang="es-CO"/>
-          </a:p>
-        </p:txBody>
-      </p:sp>
-      <p:sp>
-        <p:nvSpPr>
-          <p:cNvPr id="15" name="Text 12"/>
-          <p:cNvSpPr/>
-          <p:nvPr/>
-        </p:nvSpPr>
-        <p:spPr>
-          <a:xfrm>
-            <a:off x="548640" y="7315200"/>
-            <a:ext cx="6675120" cy="1920240"/>
-          </a:xfrm>
-          <a:prstGeom prst="rect">
-            <a:avLst/>
-          </a:prstGeom>
-          <a:noFill/>
-          <a:ln/>
-        </p:spPr>
-        <p:txBody>
-          <a:bodyPr wrap="square" rtlCol="0" anchor="ctr"/>
-          <a:lstStyle/>
-          <a:p>
-            <a:pPr marL="0" indent="0" algn="ctr">
-              <a:buNone/>
-            </a:pPr>
-            <a:r>
-              <a:rPr lang="en-US" sz="1100" i="1" dirty="0">
-                <a:solidFill>
-                  <a:srgbClr val="888888"/>
-                </a:solidFill>
-                <a:latin typeface="Calibri" pitchFamily="34" charset="0"/>
-                <a:ea typeface="Calibri" pitchFamily="34" charset="-122"/>
-                <a:cs typeface="Calibri" pitchFamily="34" charset="-120"/>
-              </a:rPr>
-              <a:t>[ photo: printed C-mount + servo test fit ]</a:t>
-            </a:r>
-            <a:endParaRPr lang="en-US" sz="1100" dirty="0"/>
           </a:p>
         </p:txBody>
       </p:sp>
@@ -5796,6 +5901,36 @@
           </a:p>
         </p:txBody>
       </p:sp>
+      <p:pic>
+        <p:nvPicPr>
+          <p:cNvPr id="22" name="Imagen 21">
+            <a:extLst>
+              <a:ext uri="{FF2B5EF4-FFF2-40B4-BE49-F238E27FC236}">
+                <a16:creationId xmlns:a16="http://schemas.microsoft.com/office/drawing/2014/main" id="{B63E306E-06AF-882B-3B33-9901092457C8}"/>
+              </a:ext>
+            </a:extLst>
+          </p:cNvPr>
+          <p:cNvPicPr>
+            <a:picLocks noChangeAspect="1"/>
+          </p:cNvPicPr>
+          <p:nvPr/>
+        </p:nvPicPr>
+        <p:blipFill>
+          <a:blip r:embed="rId3"/>
+          <a:stretch>
+            <a:fillRect/>
+          </a:stretch>
+        </p:blipFill>
+        <p:spPr>
+          <a:xfrm>
+            <a:off x="5358222" y="2377440"/>
+            <a:ext cx="1499778" cy="2072864"/>
+          </a:xfrm>
+          <a:prstGeom prst="rect">
+            <a:avLst/>
+          </a:prstGeom>
+        </p:spPr>
+      </p:pic>
     </p:spTree>
   </p:cSld>
   <p:clrMapOvr>
@@ -7432,77 +7567,6 @@
               <a:t>All the arm lengths, angles, joints, loads, and the axle span are tied to the wheelbase (unchanged), so they all held. Only the old wheelbase-from-chassis formula broke - now they're independent, which is the whole point.</a:t>
             </a:r>
             <a:endParaRPr lang="en-US" sz="1000" dirty="0"/>
-          </a:p>
-        </p:txBody>
-      </p:sp>
-      <p:sp>
-        <p:nvSpPr>
-          <p:cNvPr id="12" name="Shape 9"/>
-          <p:cNvSpPr/>
-          <p:nvPr/>
-        </p:nvSpPr>
-        <p:spPr>
-          <a:xfrm>
-            <a:off x="457200" y="7498080"/>
-            <a:ext cx="6858000" cy="1737360"/>
-          </a:xfrm>
-          <a:prstGeom prst="rect">
-            <a:avLst/>
-          </a:prstGeom>
-          <a:solidFill>
-            <a:srgbClr val="F4F4F0"/>
-          </a:solidFill>
-          <a:ln w="12700">
-            <a:solidFill>
-              <a:srgbClr val="999999"/>
-            </a:solidFill>
-            <a:prstDash val="dash"/>
-          </a:ln>
-        </p:spPr>
-        <p:txBody>
-          <a:bodyPr/>
-          <a:lstStyle/>
-          <a:p>
-            <a:endParaRPr lang="es-CO"/>
-          </a:p>
-        </p:txBody>
-      </p:sp>
-      <p:sp>
-        <p:nvSpPr>
-          <p:cNvPr id="7" name="Text 10"/>
-          <p:cNvSpPr/>
-          <p:nvPr/>
-        </p:nvSpPr>
-        <p:spPr>
-          <a:xfrm>
-            <a:off x="548640" y="7498080"/>
-            <a:ext cx="6675120" cy="1737360"/>
-          </a:xfrm>
-          <a:prstGeom prst="rect">
-            <a:avLst/>
-          </a:prstGeom>
-          <a:noFill/>
-          <a:ln/>
-        </p:spPr>
-        <p:txBody>
-          <a:bodyPr wrap="square" rtlCol="0" anchor="ctr"/>
-          <a:lstStyle/>
-          <a:p>
-            <a:pPr marL="0" indent="0" algn="ctr">
-              <a:buNone/>
-            </a:pPr>
-            <a:r>
-              <a:rPr lang="en-US" sz="1100" i="1" dirty="0">
-                <a:solidFill>
-                  <a:srgbClr val="888888"/>
-                </a:solidFill>
-                <a:latin typeface="Calibri" pitchFamily="34" charset="0"/>
-                <a:ea typeface="Calibri" pitchFamily="34" charset="-122"/>
-                <a:cs typeface="Calibri" pitchFamily="34" charset="-120"/>
-              </a:rPr>
-              <a:t>[ sketch: top view, wheels wrapping the 900x600 body ]</a:t>
-            </a:r>
-            <a:endParaRPr lang="en-US" sz="1100" dirty="0"/>
           </a:p>
         </p:txBody>
       </p:sp>
@@ -10245,45 +10309,6 @@
       </p:sp>
       <p:sp>
         <p:nvSpPr>
-          <p:cNvPr id="8" name="Text 11"/>
-          <p:cNvSpPr/>
-          <p:nvPr/>
-        </p:nvSpPr>
-        <p:spPr>
-          <a:xfrm>
-            <a:off x="548640" y="7772400"/>
-            <a:ext cx="6675120" cy="1463040"/>
-          </a:xfrm>
-          <a:prstGeom prst="rect">
-            <a:avLst/>
-          </a:prstGeom>
-          <a:noFill/>
-          <a:ln/>
-        </p:spPr>
-        <p:txBody>
-          <a:bodyPr wrap="square" rtlCol="0" anchor="ctr"/>
-          <a:lstStyle/>
-          <a:p>
-            <a:pPr marL="0" indent="0" algn="ctr">
-              <a:buNone/>
-            </a:pPr>
-            <a:r>
-              <a:rPr lang="en-US" sz="1100" i="1" dirty="0">
-                <a:solidFill>
-                  <a:srgbClr val="888888"/>
-                </a:solidFill>
-                <a:latin typeface="Calibri" pitchFamily="34" charset="0"/>
-                <a:ea typeface="Calibri" pitchFamily="34" charset="-122"/>
-                <a:cs typeface="Calibri" pitchFamily="34" charset="-120"/>
-              </a:rPr>
-              <a:t>[ photo: motors + drivers once they arrive ]</a:t>
-            </a:r>
-            <a:endParaRPr lang="en-US" sz="1100" dirty="0"/>
-          </a:p>
-        </p:txBody>
-      </p:sp>
-      <p:sp>
-        <p:nvSpPr>
           <p:cNvPr id="15" name="Shape 12"/>
           <p:cNvSpPr/>
           <p:nvPr/>
@@ -13319,77 +13344,6 @@
       </p:sp>
       <p:sp>
         <p:nvSpPr>
-          <p:cNvPr id="10" name="Shape 7"/>
-          <p:cNvSpPr/>
-          <p:nvPr/>
-        </p:nvSpPr>
-        <p:spPr>
-          <a:xfrm>
-            <a:off x="457200" y="7498080"/>
-            <a:ext cx="6858000" cy="1737360"/>
-          </a:xfrm>
-          <a:prstGeom prst="rect">
-            <a:avLst/>
-          </a:prstGeom>
-          <a:solidFill>
-            <a:srgbClr val="F4F4F0"/>
-          </a:solidFill>
-          <a:ln w="12700">
-            <a:solidFill>
-              <a:srgbClr val="999999"/>
-            </a:solidFill>
-            <a:prstDash val="dash"/>
-          </a:ln>
-        </p:spPr>
-        <p:txBody>
-          <a:bodyPr/>
-          <a:lstStyle/>
-          <a:p>
-            <a:endParaRPr lang="es-CO"/>
-          </a:p>
-        </p:txBody>
-      </p:sp>
-      <p:sp>
-        <p:nvSpPr>
-          <p:cNvPr id="11" name="Text 8"/>
-          <p:cNvSpPr/>
-          <p:nvPr/>
-        </p:nvSpPr>
-        <p:spPr>
-          <a:xfrm>
-            <a:off x="548640" y="7498080"/>
-            <a:ext cx="6675120" cy="1737360"/>
-          </a:xfrm>
-          <a:prstGeom prst="rect">
-            <a:avLst/>
-          </a:prstGeom>
-          <a:noFill/>
-          <a:ln/>
-        </p:spPr>
-        <p:txBody>
-          <a:bodyPr wrap="square" rtlCol="0" anchor="ctr"/>
-          <a:lstStyle/>
-          <a:p>
-            <a:pPr marL="0" indent="0" algn="ctr">
-              <a:buNone/>
-            </a:pPr>
-            <a:r>
-              <a:rPr lang="en-US" sz="1100" i="1" dirty="0">
-                <a:solidFill>
-                  <a:srgbClr val="888888"/>
-                </a:solidFill>
-                <a:latin typeface="Calibri" pitchFamily="34" charset="0"/>
-                <a:ea typeface="Calibri" pitchFamily="34" charset="-122"/>
-                <a:cs typeface="Calibri" pitchFamily="34" charset="-120"/>
-              </a:rPr>
-              <a:t>[ Fusion screenshot: FEA stress plot on the rocker (once solved) ]</a:t>
-            </a:r>
-            <a:endParaRPr lang="en-US" sz="1100" dirty="0"/>
-          </a:p>
-        </p:txBody>
-      </p:sp>
-      <p:sp>
-        <p:nvSpPr>
           <p:cNvPr id="12" name="Shape 9"/>
           <p:cNvSpPr/>
           <p:nvPr/>
@@ -16212,45 +16166,6 @@
           <a:lstStyle/>
           <a:p>
             <a:endParaRPr lang="es-CO"/>
-          </a:p>
-        </p:txBody>
-      </p:sp>
-      <p:sp>
-        <p:nvSpPr>
-          <p:cNvPr id="9" name="Text 6"/>
-          <p:cNvSpPr/>
-          <p:nvPr/>
-        </p:nvSpPr>
-        <p:spPr>
-          <a:xfrm>
-            <a:off x="548640" y="7726680"/>
-            <a:ext cx="6675120" cy="1508760"/>
-          </a:xfrm>
-          <a:prstGeom prst="rect">
-            <a:avLst/>
-          </a:prstGeom>
-          <a:noFill/>
-          <a:ln/>
-        </p:spPr>
-        <p:txBody>
-          <a:bodyPr wrap="square" rtlCol="0" anchor="ctr"/>
-          <a:lstStyle/>
-          <a:p>
-            <a:pPr marL="0" indent="0" algn="ctr">
-              <a:buNone/>
-            </a:pPr>
-            <a:r>
-              <a:rPr lang="en-US" sz="1100" i="1" dirty="0">
-                <a:solidFill>
-                  <a:srgbClr val="888888"/>
-                </a:solidFill>
-                <a:latin typeface="Calibri" pitchFamily="34" charset="0"/>
-                <a:ea typeface="Calibri" pitchFamily="34" charset="-122"/>
-                <a:cs typeface="Calibri" pitchFamily="34" charset="-120"/>
-              </a:rPr>
-              <a:t>[ photo: parts laid out once they arrive ]</a:t>
-            </a:r>
-            <a:endParaRPr lang="en-US" sz="1100" dirty="0"/>
           </a:p>
         </p:txBody>
       </p:sp>
@@ -20257,45 +20172,6 @@
       </p:sp>
       <p:sp>
         <p:nvSpPr>
-          <p:cNvPr id="11" name="Text 9"/>
-          <p:cNvSpPr/>
-          <p:nvPr/>
-        </p:nvSpPr>
-        <p:spPr>
-          <a:xfrm>
-            <a:off x="548640" y="6400800"/>
-            <a:ext cx="6675120" cy="2834640"/>
-          </a:xfrm>
-          <a:prstGeom prst="rect">
-            <a:avLst/>
-          </a:prstGeom>
-          <a:noFill/>
-          <a:ln/>
-        </p:spPr>
-        <p:txBody>
-          <a:bodyPr wrap="square" rtlCol="0" anchor="ctr"/>
-          <a:lstStyle/>
-          <a:p>
-            <a:pPr marL="0" indent="0" algn="ctr">
-              <a:buNone/>
-            </a:pPr>
-            <a:r>
-              <a:rPr lang="en-US" sz="1100" i="1" dirty="0">
-                <a:solidFill>
-                  <a:srgbClr val="888888"/>
-                </a:solidFill>
-                <a:latin typeface="Calibri" pitchFamily="34" charset="0"/>
-                <a:ea typeface="Calibri" pitchFamily="34" charset="-122"/>
-                <a:cs typeface="Calibri" pitchFamily="34" charset="-120"/>
-              </a:rPr>
-              <a:t>[ hand sketch]</a:t>
-            </a:r>
-            <a:endParaRPr lang="en-US" sz="1100" dirty="0"/>
-          </a:p>
-        </p:txBody>
-      </p:sp>
-      <p:sp>
-        <p:nvSpPr>
           <p:cNvPr id="12" name="Shape 10"/>
           <p:cNvSpPr/>
           <p:nvPr/>
@@ -22886,77 +22762,6 @@
               <a:t>Big realization: I stopped tying the wheelbase to the chassis length. Keeping them independent is what let me shrink the body to 900 mm while keeping a 1000 mm wheelbase - so the wheels wrap the body.</a:t>
             </a:r>
             <a:endParaRPr lang="en-US" sz="1000" dirty="0"/>
-          </a:p>
-        </p:txBody>
-      </p:sp>
-      <p:sp>
-        <p:nvSpPr>
-          <p:cNvPr id="10" name="Shape 7"/>
-          <p:cNvSpPr/>
-          <p:nvPr/>
-        </p:nvSpPr>
-        <p:spPr>
-          <a:xfrm>
-            <a:off x="457200" y="7498080"/>
-            <a:ext cx="6858000" cy="1737360"/>
-          </a:xfrm>
-          <a:prstGeom prst="rect">
-            <a:avLst/>
-          </a:prstGeom>
-          <a:solidFill>
-            <a:srgbClr val="F4F4F0"/>
-          </a:solidFill>
-          <a:ln w="12700">
-            <a:solidFill>
-              <a:srgbClr val="999999"/>
-            </a:solidFill>
-            <a:prstDash val="dash"/>
-          </a:ln>
-        </p:spPr>
-        <p:txBody>
-          <a:bodyPr/>
-          <a:lstStyle/>
-          <a:p>
-            <a:endParaRPr lang="es-CO"/>
-          </a:p>
-        </p:txBody>
-      </p:sp>
-      <p:sp>
-        <p:nvSpPr>
-          <p:cNvPr id="11" name="Text 8"/>
-          <p:cNvSpPr/>
-          <p:nvPr/>
-        </p:nvSpPr>
-        <p:spPr>
-          <a:xfrm>
-            <a:off x="548640" y="7498080"/>
-            <a:ext cx="6675120" cy="1737360"/>
-          </a:xfrm>
-          <a:prstGeom prst="rect">
-            <a:avLst/>
-          </a:prstGeom>
-          <a:noFill/>
-          <a:ln/>
-        </p:spPr>
-        <p:txBody>
-          <a:bodyPr wrap="square" rtlCol="0" anchor="ctr"/>
-          <a:lstStyle/>
-          <a:p>
-            <a:pPr marL="0" indent="0" algn="ctr">
-              <a:buNone/>
-            </a:pPr>
-            <a:r>
-              <a:rPr lang="en-US" sz="1100" i="1" dirty="0">
-                <a:solidFill>
-                  <a:srgbClr val="888888"/>
-                </a:solidFill>
-                <a:latin typeface="Calibri" pitchFamily="34" charset="0"/>
-                <a:ea typeface="Calibri" pitchFamily="34" charset="-122"/>
-                <a:cs typeface="Calibri" pitchFamily="34" charset="-120"/>
-              </a:rPr>
-              <a:t>[ photos maybe?]</a:t>
-            </a:r>
-            <a:endParaRPr lang="en-US" sz="1100" dirty="0"/>
           </a:p>
         </p:txBody>
       </p:sp>
@@ -23669,77 +23474,6 @@
       </p:sp>
       <p:sp>
         <p:nvSpPr>
-          <p:cNvPr id="12" name="Shape 10"/>
-          <p:cNvSpPr/>
-          <p:nvPr/>
-        </p:nvSpPr>
-        <p:spPr>
-          <a:xfrm>
-            <a:off x="457200" y="7223760"/>
-            <a:ext cx="6858000" cy="2011680"/>
-          </a:xfrm>
-          <a:prstGeom prst="rect">
-            <a:avLst/>
-          </a:prstGeom>
-          <a:solidFill>
-            <a:srgbClr val="F4F4F0"/>
-          </a:solidFill>
-          <a:ln w="12700">
-            <a:solidFill>
-              <a:srgbClr val="999999"/>
-            </a:solidFill>
-            <a:prstDash val="dash"/>
-          </a:ln>
-        </p:spPr>
-        <p:txBody>
-          <a:bodyPr/>
-          <a:lstStyle/>
-          <a:p>
-            <a:endParaRPr lang="es-CO"/>
-          </a:p>
-        </p:txBody>
-      </p:sp>
-      <p:sp>
-        <p:nvSpPr>
-          <p:cNvPr id="13" name="Text 11"/>
-          <p:cNvSpPr/>
-          <p:nvPr/>
-        </p:nvSpPr>
-        <p:spPr>
-          <a:xfrm>
-            <a:off x="548640" y="7223760"/>
-            <a:ext cx="6675120" cy="2011680"/>
-          </a:xfrm>
-          <a:prstGeom prst="rect">
-            <a:avLst/>
-          </a:prstGeom>
-          <a:noFill/>
-          <a:ln/>
-        </p:spPr>
-        <p:txBody>
-          <a:bodyPr wrap="square" rtlCol="0" anchor="ctr"/>
-          <a:lstStyle/>
-          <a:p>
-            <a:pPr marL="0" indent="0" algn="ctr">
-              <a:buNone/>
-            </a:pPr>
-            <a:r>
-              <a:rPr lang="en-US" sz="1100" i="1" dirty="0">
-                <a:solidFill>
-                  <a:srgbClr val="888888"/>
-                </a:solidFill>
-                <a:latin typeface="Calibri" pitchFamily="34" charset="0"/>
-                <a:ea typeface="Calibri" pitchFamily="34" charset="-122"/>
-                <a:cs typeface="Calibri" pitchFamily="34" charset="-120"/>
-              </a:rPr>
-              <a:t>[ sketch of  case1 case2]</a:t>
-            </a:r>
-            <a:endParaRPr lang="en-US" sz="1100" dirty="0"/>
-          </a:p>
-        </p:txBody>
-      </p:sp>
-      <p:sp>
-        <p:nvSpPr>
           <p:cNvPr id="14" name="Shape 12"/>
           <p:cNvSpPr/>
           <p:nvPr/>
@@ -25511,45 +25245,6 @@
       </p:sp>
       <p:sp>
         <p:nvSpPr>
-          <p:cNvPr id="10" name="Text 7"/>
-          <p:cNvSpPr/>
-          <p:nvPr/>
-        </p:nvSpPr>
-        <p:spPr>
-          <a:xfrm>
-            <a:off x="4937760" y="2606040"/>
-            <a:ext cx="2286000" cy="1874520"/>
-          </a:xfrm>
-          <a:prstGeom prst="rect">
-            <a:avLst/>
-          </a:prstGeom>
-          <a:noFill/>
-          <a:ln/>
-        </p:spPr>
-        <p:txBody>
-          <a:bodyPr wrap="square" rtlCol="0" anchor="ctr"/>
-          <a:lstStyle/>
-          <a:p>
-            <a:pPr marL="0" indent="0" algn="ctr">
-              <a:buNone/>
-            </a:pPr>
-            <a:r>
-              <a:rPr lang="en-US" sz="1100" i="1" dirty="0">
-                <a:solidFill>
-                  <a:srgbClr val="888888"/>
-                </a:solidFill>
-                <a:latin typeface="Calibri" pitchFamily="34" charset="0"/>
-                <a:ea typeface="Calibri" pitchFamily="34" charset="-122"/>
-                <a:cs typeface="Calibri" pitchFamily="34" charset="-120"/>
-              </a:rPr>
-              <a:t>[ sketch wheel ]</a:t>
-            </a:r>
-            <a:endParaRPr lang="en-US" sz="1100" dirty="0"/>
-          </a:p>
-        </p:txBody>
-      </p:sp>
-      <p:sp>
-        <p:nvSpPr>
           <p:cNvPr id="11" name="Text 8"/>
           <p:cNvSpPr/>
           <p:nvPr/>
@@ -25782,45 +25477,6 @@
       </p:sp>
       <p:sp>
         <p:nvSpPr>
-          <p:cNvPr id="16" name="Text 13"/>
-          <p:cNvSpPr/>
-          <p:nvPr/>
-        </p:nvSpPr>
-        <p:spPr>
-          <a:xfrm>
-            <a:off x="548640" y="7269480"/>
-            <a:ext cx="6675120" cy="1965960"/>
-          </a:xfrm>
-          <a:prstGeom prst="rect">
-            <a:avLst/>
-          </a:prstGeom>
-          <a:noFill/>
-          <a:ln/>
-        </p:spPr>
-        <p:txBody>
-          <a:bodyPr wrap="square" rtlCol="0" anchor="ctr"/>
-          <a:lstStyle/>
-          <a:p>
-            <a:pPr marL="0" indent="0" algn="ctr">
-              <a:buNone/>
-            </a:pPr>
-            <a:r>
-              <a:rPr lang="en-US" sz="1100" i="1" dirty="0">
-                <a:solidFill>
-                  <a:srgbClr val="888888"/>
-                </a:solidFill>
-                <a:latin typeface="Calibri" pitchFamily="34" charset="0"/>
-                <a:ea typeface="Calibri" pitchFamily="34" charset="-122"/>
-                <a:cs typeface="Calibri" pitchFamily="34" charset="-120"/>
-              </a:rPr>
-              <a:t>[ ISO drawing: rocker &amp; bogie tube dimensions - sheet 01/04 ]</a:t>
-            </a:r>
-            <a:endParaRPr lang="en-US" sz="1100" dirty="0"/>
-          </a:p>
-        </p:txBody>
-      </p:sp>
-      <p:sp>
-        <p:nvSpPr>
           <p:cNvPr id="17" name="Shape 14"/>
           <p:cNvSpPr/>
           <p:nvPr/>
@@ -26038,6 +25694,36 @@
           </a:p>
         </p:txBody>
       </p:sp>
+      <p:pic>
+        <p:nvPicPr>
+          <p:cNvPr id="23" name="Imagen 22">
+            <a:extLst>
+              <a:ext uri="{FF2B5EF4-FFF2-40B4-BE49-F238E27FC236}">
+                <a16:creationId xmlns:a16="http://schemas.microsoft.com/office/drawing/2014/main" id="{D8680344-AB4D-812B-610A-1FE22BA92EB2}"/>
+              </a:ext>
+            </a:extLst>
+          </p:cNvPr>
+          <p:cNvPicPr>
+            <a:picLocks noChangeAspect="1"/>
+          </p:cNvPicPr>
+          <p:nvPr/>
+        </p:nvPicPr>
+        <p:blipFill>
+          <a:blip r:embed="rId3"/>
+          <a:stretch>
+            <a:fillRect/>
+          </a:stretch>
+        </p:blipFill>
+        <p:spPr>
+          <a:xfrm>
+            <a:off x="4846205" y="2572210"/>
+            <a:ext cx="2468995" cy="1915969"/>
+          </a:xfrm>
+          <a:prstGeom prst="rect">
+            <a:avLst/>
+          </a:prstGeom>
+        </p:spPr>
+      </p:pic>
     </p:spTree>
   </p:cSld>
   <p:clrMapOvr>
@@ -26510,77 +26196,6 @@
               <a:t>The 0.30/0.30/0.40 numbers sum to 1.0 over a 3-wheel train. For the FEA I'm treating them as a worst-case load dumped on one wheel, not an average - better to over-build than find out the hard way.</a:t>
             </a:r>
             <a:endParaRPr lang="en-US" sz="1000" dirty="0"/>
-          </a:p>
-        </p:txBody>
-      </p:sp>
-      <p:sp>
-        <p:nvSpPr>
-          <p:cNvPr id="13" name="Shape 11"/>
-          <p:cNvSpPr/>
-          <p:nvPr/>
-        </p:nvSpPr>
-        <p:spPr>
-          <a:xfrm>
-            <a:off x="457200" y="7223760"/>
-            <a:ext cx="6858000" cy="2011680"/>
-          </a:xfrm>
-          <a:prstGeom prst="rect">
-            <a:avLst/>
-          </a:prstGeom>
-          <a:solidFill>
-            <a:srgbClr val="F4F4F0"/>
-          </a:solidFill>
-          <a:ln w="12700">
-            <a:solidFill>
-              <a:srgbClr val="999999"/>
-            </a:solidFill>
-            <a:prstDash val="dash"/>
-          </a:ln>
-        </p:spPr>
-        <p:txBody>
-          <a:bodyPr/>
-          <a:lstStyle/>
-          <a:p>
-            <a:endParaRPr lang="es-CO"/>
-          </a:p>
-        </p:txBody>
-      </p:sp>
-      <p:sp>
-        <p:nvSpPr>
-          <p:cNvPr id="14" name="Text 12"/>
-          <p:cNvSpPr/>
-          <p:nvPr/>
-        </p:nvSpPr>
-        <p:spPr>
-          <a:xfrm>
-            <a:off x="548640" y="7223760"/>
-            <a:ext cx="6675120" cy="2011680"/>
-          </a:xfrm>
-          <a:prstGeom prst="rect">
-            <a:avLst/>
-          </a:prstGeom>
-          <a:noFill/>
-          <a:ln/>
-        </p:spPr>
-        <p:txBody>
-          <a:bodyPr wrap="square" rtlCol="0" anchor="ctr"/>
-          <a:lstStyle/>
-          <a:p>
-            <a:pPr marL="0" indent="0" algn="ctr">
-              <a:buNone/>
-            </a:pPr>
-            <a:r>
-              <a:rPr lang="en-US" sz="1100" i="1" dirty="0">
-                <a:solidFill>
-                  <a:srgbClr val="888888"/>
-                </a:solidFill>
-                <a:latin typeface="Calibri" pitchFamily="34" charset="0"/>
-                <a:ea typeface="Calibri" pitchFamily="34" charset="-122"/>
-                <a:cs typeface="Calibri" pitchFamily="34" charset="-120"/>
-              </a:rPr>
-              <a:t>[ Photo : maybe?]</a:t>
-            </a:r>
-            <a:endParaRPr lang="en-US" sz="1100" dirty="0"/>
           </a:p>
         </p:txBody>
       </p:sp>
@@ -28141,45 +27756,6 @@
           </a:p>
         </p:txBody>
       </p:sp>
-      <p:sp>
-        <p:nvSpPr>
-          <p:cNvPr id="8" name="Text 5"/>
-          <p:cNvSpPr/>
-          <p:nvPr/>
-        </p:nvSpPr>
-        <p:spPr>
-          <a:xfrm>
-            <a:off x="4846320" y="2286000"/>
-            <a:ext cx="2377440" cy="1325880"/>
-          </a:xfrm>
-          <a:prstGeom prst="rect">
-            <a:avLst/>
-          </a:prstGeom>
-          <a:noFill/>
-          <a:ln/>
-        </p:spPr>
-        <p:txBody>
-          <a:bodyPr wrap="square" rtlCol="0" anchor="ctr"/>
-          <a:lstStyle/>
-          <a:p>
-            <a:pPr marL="0" indent="0" algn="ctr">
-              <a:buNone/>
-            </a:pPr>
-            <a:r>
-              <a:rPr lang="en-US" sz="1100" i="1" dirty="0">
-                <a:solidFill>
-                  <a:srgbClr val="888888"/>
-                </a:solidFill>
-                <a:latin typeface="Calibri" pitchFamily="34" charset="0"/>
-                <a:ea typeface="Calibri" pitchFamily="34" charset="-122"/>
-                <a:cs typeface="Calibri" pitchFamily="34" charset="-120"/>
-              </a:rPr>
-              <a:t>[ ISO: printed joint ]</a:t>
-            </a:r>
-            <a:endParaRPr lang="en-US" sz="1100" dirty="0"/>
-          </a:p>
-        </p:txBody>
-      </p:sp>
       <p:graphicFrame>
         <p:nvGraphicFramePr>
           <p:cNvPr id="17" name="Table 1"/>
@@ -29232,45 +28808,6 @@
           <a:lstStyle/>
           <a:p>
             <a:endParaRPr lang="es-CO"/>
-          </a:p>
-        </p:txBody>
-      </p:sp>
-      <p:sp>
-        <p:nvSpPr>
-          <p:cNvPr id="15" name="Text 11"/>
-          <p:cNvSpPr/>
-          <p:nvPr/>
-        </p:nvSpPr>
-        <p:spPr>
-          <a:xfrm>
-            <a:off x="548640" y="6858000"/>
-            <a:ext cx="6675120" cy="2377440"/>
-          </a:xfrm>
-          <a:prstGeom prst="rect">
-            <a:avLst/>
-          </a:prstGeom>
-          <a:noFill/>
-          <a:ln/>
-        </p:spPr>
-        <p:txBody>
-          <a:bodyPr wrap="square" rtlCol="0" anchor="ctr"/>
-          <a:lstStyle/>
-          <a:p>
-            <a:pPr marL="0" indent="0" algn="ctr">
-              <a:buNone/>
-            </a:pPr>
-            <a:r>
-              <a:rPr lang="en-US" sz="1100" i="1" dirty="0">
-                <a:solidFill>
-                  <a:srgbClr val="888888"/>
-                </a:solidFill>
-                <a:latin typeface="Calibri" pitchFamily="34" charset="0"/>
-                <a:ea typeface="Calibri" pitchFamily="34" charset="-122"/>
-                <a:cs typeface="Calibri" pitchFamily="34" charset="-120"/>
-              </a:rPr>
-              <a:t>[ ISO drawing: 3D-printed joints A &amp; B with socket insertion - sheet 02 ]</a:t>
-            </a:r>
-            <a:endParaRPr lang="en-US" sz="1100" dirty="0"/>
           </a:p>
         </p:txBody>
       </p:sp>
@@ -29932,77 +29469,6 @@
               <a:t>For a competition rover where rough terrain is the whole point, real leveling is worth the extra parts. I went with a printed version of NASA's mechanism: a balancin that rocks, two bieletas down to clamps on the rockers. Got it moving right in the Fusion Motion Study.</a:t>
             </a:r>
             <a:endParaRPr lang="en-US" sz="1000" dirty="0"/>
-          </a:p>
-        </p:txBody>
-      </p:sp>
-      <p:sp>
-        <p:nvSpPr>
-          <p:cNvPr id="12" name="Shape 10"/>
-          <p:cNvSpPr/>
-          <p:nvPr/>
-        </p:nvSpPr>
-        <p:spPr>
-          <a:xfrm>
-            <a:off x="457200" y="7543800"/>
-            <a:ext cx="6858000" cy="1691640"/>
-          </a:xfrm>
-          <a:prstGeom prst="rect">
-            <a:avLst/>
-          </a:prstGeom>
-          <a:solidFill>
-            <a:srgbClr val="F4F4F0"/>
-          </a:solidFill>
-          <a:ln w="12700">
-            <a:solidFill>
-              <a:srgbClr val="999999"/>
-            </a:solidFill>
-            <a:prstDash val="dash"/>
-          </a:ln>
-        </p:spPr>
-        <p:txBody>
-          <a:bodyPr/>
-          <a:lstStyle/>
-          <a:p>
-            <a:endParaRPr lang="es-CO"/>
-          </a:p>
-        </p:txBody>
-      </p:sp>
-      <p:sp>
-        <p:nvSpPr>
-          <p:cNvPr id="13" name="Text 11"/>
-          <p:cNvSpPr/>
-          <p:nvPr/>
-        </p:nvSpPr>
-        <p:spPr>
-          <a:xfrm>
-            <a:off x="548640" y="7543800"/>
-            <a:ext cx="6675120" cy="1691640"/>
-          </a:xfrm>
-          <a:prstGeom prst="rect">
-            <a:avLst/>
-          </a:prstGeom>
-          <a:noFill/>
-          <a:ln/>
-        </p:spPr>
-        <p:txBody>
-          <a:bodyPr wrap="square" rtlCol="0" anchor="ctr"/>
-          <a:lstStyle/>
-          <a:p>
-            <a:pPr marL="0" indent="0" algn="ctr">
-              <a:buNone/>
-            </a:pPr>
-            <a:r>
-              <a:rPr lang="en-US" sz="1100" i="1" dirty="0">
-                <a:solidFill>
-                  <a:srgbClr val="888888"/>
-                </a:solidFill>
-                <a:latin typeface="Calibri" pitchFamily="34" charset="0"/>
-                <a:ea typeface="Calibri" pitchFamily="34" charset="-122"/>
-                <a:cs typeface="Calibri" pitchFamily="34" charset="-120"/>
-              </a:rPr>
-              <a:t>[ ISO: rigid bar (wrong) vs balancin + bieletas (right) ]</a:t>
-            </a:r>
-            <a:endParaRPr lang="en-US" sz="1100" dirty="0"/>
           </a:p>
         </p:txBody>
       </p:sp>

</xml_diff>

<commit_message>
Update BOM from real purchase, add wheel-joint STLs, journal pages, and steering animation
- BOM: reconcile bom_rover.csv against the real invoice (Pedido S174842) -
  motors, drivers, servos, 2020 profile, filament, and the Arduino UNO Q
  brain are now marked Comprado with real prices; everything else stays
  Pendiente.
- Parts/STL-parts/Bogie: export the final steering-knuckle geometry
  (printed bearing + real 30/10deg angles) plus mirrored left-side
  variants (JuntaLlanta/Estatica/Direccion + ...I), replacing the
  pre-redesign STLs.
- Journal: add 3 new pages (wheel-joint redesign, the real order + brain
  swap, current status/next steps) and update the Table of Contents.
- README: new "Wheel-corner assembly" section, trimmed BOM section that
  points to the CSV, a steering-sweep GIF captured from the live Fusion
  assembly, and a Build journal pointer.
</commit_message>
<xml_diff>
--- a/Journal/Librito_Rover x_x (CreacionSistemaMecanico) .pptx
+++ b/Journal/Librito_Rover x_x (CreacionSistemaMecanico) .pptx
@@ -23,6 +23,9 @@
     <p:sldId id="268" r:id="rId14"/>
     <p:sldId id="269" r:id="rId15"/>
     <p:sldId id="270" r:id="rId16"/>
+    <p:sldId id="271" r:id="rId23"/>
+    <p:sldId id="272" r:id="rId24"/>
+    <p:sldId id="273" r:id="rId25"/>
   </p:sldIdLst>
   <p:sldSz cx="7772400" cy="10058400"/>
   <p:notesSz cx="10058400" cy="7772400"/>
@@ -16396,6 +16399,1959 @@
 </p:sld>
 </file>
 
+<file path=ppt/slides/slide16.xml><?xml version="1.0" encoding="utf-8"?>
+<p:sld xmlns:a="http://schemas.openxmlformats.org/drawingml/2006/main" xmlns:p="http://schemas.openxmlformats.org/presentationml/2006/main" xmlns:r="http://schemas.openxmlformats.org/officeDocument/2006/relationships">
+  <p:cSld>
+    <p:spTree>
+      <p:nvGrpSpPr>
+        <p:cNvPr id="1" name=""/>
+        <p:cNvGrpSpPr/>
+        <p:nvPr/>
+      </p:nvGrpSpPr>
+      <p:grpSpPr/>
+      <p:sp>
+        <p:nvSpPr>
+          <p:cNvPr id="2" name="Shape 0"/>
+          <p:cNvSpPr/>
+          <p:nvPr/>
+        </p:nvSpPr>
+        <p:spPr>
+          <a:xfrm>
+            <a:off x="457200" y="457200"/>
+            <a:ext cx="6858000" cy="457200"/>
+          </a:xfrm>
+          <a:prstGeom prst="rect">
+            <a:avLst/>
+          </a:prstGeom>
+          <a:solidFill>
+            <a:srgbClr val="A6192E"/>
+          </a:solidFill>
+          <a:ln/>
+        </p:spPr>
+        <p:txBody>
+          <a:bodyPr/>
+          <a:lstStyle/>
+          <a:p>
+            <a:endParaRPr lang="es-CO"/>
+          </a:p>
+        </p:txBody>
+      </p:sp>
+      <p:sp>
+        <p:nvSpPr>
+          <p:cNvPr id="3" name="Text 1"/>
+          <p:cNvSpPr/>
+          <p:nvPr/>
+        </p:nvSpPr>
+        <p:spPr>
+          <a:xfrm>
+            <a:off x="594360" y="457200"/>
+            <a:ext cx="6583680" cy="457200"/>
+          </a:xfrm>
+          <a:prstGeom prst="rect">
+            <a:avLst/>
+          </a:prstGeom>
+          <a:noFill/>
+          <a:ln/>
+        </p:spPr>
+        <p:txBody>
+          <a:bodyPr wrap="square" rtlCol="0" anchor="ctr"/>
+          <a:lstStyle/>
+          <a:p>
+            <a:pPr marL="0" indent="0">
+              <a:buNone/>
+            </a:pPr>
+            <a:r>
+              <a:rPr lang="en-US" sz="1800" b="1" dirty="0">
+                <a:solidFill>
+                  <a:srgbClr val="FFFFFF"/>
+                </a:solidFill>
+                <a:latin typeface="Cambria" pitchFamily="34" charset="0"/>
+                <a:ea typeface="Cambria" pitchFamily="34" charset="-122"/>
+                <a:cs typeface="Cambria" pitchFamily="34" charset="-120"/>
+              </a:rPr>
+              <a:t>Redesigning the wheel joint: bearing + real angles</a:t>
+            </a:r>
+            <a:endParaRPr lang="en-US" sz="1800" dirty="0"/>
+          </a:p>
+        </p:txBody>
+      </p:sp>
+      <p:sp>
+        <p:nvSpPr>
+          <p:cNvPr id="4" name="Text 2"/>
+          <p:cNvSpPr/>
+          <p:nvPr/>
+        </p:nvSpPr>
+        <p:spPr>
+          <a:xfrm>
+            <a:off x="457200" y="1097280"/>
+            <a:ext cx="1828800" cy="274320"/>
+          </a:xfrm>
+          <a:prstGeom prst="rect">
+            <a:avLst/>
+          </a:prstGeom>
+          <a:solidFill>
+            <a:srgbClr val="E8929C"/>
+          </a:solidFill>
+          <a:ln/>
+        </p:spPr>
+        <p:txBody>
+          <a:bodyPr wrap="square" rtlCol="0" anchor="ctr"/>
+          <a:lstStyle/>
+          <a:p>
+            <a:pPr marL="0" indent="0" algn="ctr">
+              <a:buNone/>
+            </a:pPr>
+            <a:r>
+              <a:rPr lang="en-US" sz="1100" b="1" dirty="0">
+                <a:solidFill>
+                  <a:srgbClr val="1A1A1A"/>
+                </a:solidFill>
+                <a:latin typeface="Calibri" pitchFamily="34" charset="0"/>
+                <a:ea typeface="Calibri" pitchFamily="34" charset="-122"/>
+                <a:cs typeface="Calibri" pitchFamily="34" charset="-120"/>
+              </a:rPr>
+              <a:t>Borrowing from a proven reference</a:t>
+            </a:r>
+            <a:endParaRPr lang="en-US" sz="1100" dirty="0"/>
+          </a:p>
+        </p:txBody>
+      </p:sp>
+      <p:sp>
+        <p:nvSpPr>
+          <p:cNvPr id="5" name="Text 3"/>
+          <p:cNvSpPr/>
+          <p:nvPr/>
+        </p:nvSpPr>
+        <p:spPr>
+          <a:xfrm>
+            <a:off x="457200" y="1463040"/>
+            <a:ext cx="6858000" cy="1097280"/>
+          </a:xfrm>
+          <a:prstGeom prst="rect">
+            <a:avLst/>
+          </a:prstGeom>
+          <a:noFill/>
+          <a:ln/>
+        </p:spPr>
+        <p:txBody>
+          <a:bodyPr wrap="square" rtlCol="0" anchor="t"/>
+          <a:lstStyle/>
+          <a:p>
+            <a:pPr marL="0" indent="0">
+              <a:lnSpc>
+                <a:spcPct val="112000"/>
+              </a:lnSpc>
+              <a:buNone/>
+            </a:pPr>
+            <a:r>
+              <a:rPr lang="en-US" sz="1300" dirty="0">
+                <a:solidFill>
+                  <a:srgbClr val="1A1A1A"/>
+                </a:solidFill>
+                <a:latin typeface="Calibri" pitchFamily="34" charset="0"/>
+                <a:ea typeface="Calibri" pitchFamily="34" charset="-122"/>
+                <a:cs typeface="Calibri" pitchFamily="34" charset="-120"/>
+              </a:rPr>
+              <a:t>Instead of designing the steering knuckle from scratch, I pulled the geometry from the "Mars Rover Perseverance Replica" build (SolidWorks files, now in the Referencia folder) and reused their Servo coupler, Servo Horn, and Wheel Joint parts as-is. Checked my 37 mm gear motor (6 mm D-shaft, 31 mm bolt circle) against their "Wheel 1 Joint p2" cavity - exact fit, no scaling needed.</a:t>
+            </a:r>
+            <a:endParaRPr lang="en-US" sz="1300" dirty="0"/>
+          </a:p>
+        </p:txBody>
+      </p:sp>
+      <p:sp>
+        <p:nvSpPr>
+          <p:cNvPr id="6" name="Text 4"/>
+          <p:cNvSpPr/>
+          <p:nvPr/>
+        </p:nvSpPr>
+        <p:spPr>
+          <a:xfrm>
+            <a:off x="457200" y="2697480"/>
+            <a:ext cx="1828800" cy="274320"/>
+          </a:xfrm>
+          <a:prstGeom prst="rect">
+            <a:avLst/>
+          </a:prstGeom>
+          <a:solidFill>
+            <a:srgbClr val="FCEFA6"/>
+          </a:solidFill>
+          <a:ln/>
+        </p:spPr>
+        <p:txBody>
+          <a:bodyPr wrap="square" rtlCol="0" anchor="ctr"/>
+          <a:lstStyle/>
+          <a:p>
+            <a:pPr marL="0" indent="0" algn="ctr">
+              <a:buNone/>
+            </a:pPr>
+            <a:r>
+              <a:rPr lang="en-US" sz="1100" b="1" dirty="0">
+                <a:solidFill>
+                  <a:srgbClr val="1A1A1A"/>
+                </a:solidFill>
+                <a:latin typeface="Calibri" pitchFamily="34" charset="0"/>
+                <a:ea typeface="Calibri" pitchFamily="34" charset="-122"/>
+                <a:cs typeface="Calibri" pitchFamily="34" charset="-120"/>
+              </a:rPr>
+              <a:t>A bearing I don't have to buy</a:t>
+            </a:r>
+            <a:endParaRPr lang="en-US" sz="1100" dirty="0"/>
+          </a:p>
+        </p:txBody>
+      </p:sp>
+      <p:sp>
+        <p:nvSpPr>
+          <p:cNvPr id="7" name="Text 5"/>
+          <p:cNvSpPr/>
+          <p:nvPr/>
+        </p:nvSpPr>
+        <p:spPr>
+          <a:xfrm>
+            <a:off x="457200" y="3063240"/>
+            <a:ext cx="6858000" cy="1280160"/>
+          </a:xfrm>
+          <a:prstGeom prst="rect">
+            <a:avLst/>
+          </a:prstGeom>
+          <a:noFill/>
+          <a:ln/>
+        </p:spPr>
+        <p:txBody>
+          <a:bodyPr wrap="square" rtlCol="0" anchor="t"/>
+          <a:lstStyle/>
+          <a:p>
+            <a:pPr marL="0" indent="0">
+              <a:lnSpc>
+                <a:spcPct val="112000"/>
+              </a:lnSpc>
+              <a:buNone/>
+            </a:pPr>
+            <a:r>
+              <a:rPr lang="en-US" sz="1250" dirty="0">
+                <a:solidFill>
+                  <a:srgbClr val="1A1A1A"/>
+                </a:solidFill>
+                <a:latin typeface="Calibri" pitchFamily="34" charset="0"/>
+                <a:ea typeface="Calibri" pitchFamily="34" charset="-122"/>
+                <a:cs typeface="Calibri" pitchFamily="34" charset="-120"/>
+              </a:rPr>
+              <a:t>The knuckle needed a bearing between the servo coupler and the wheel shaft. Instead of buying one, I generated a print-in-place ball bearing in OpenSCAD (BOSL2 library) sized to the "635" standard - ID5/OD19/W6mm, dumbbell rollers, 0.15mm clearance. Prints straight into the socket, no purchased part.</a:t>
+            </a:r>
+            <a:endParaRPr lang="en-US" sz="1250" dirty="0"/>
+          </a:p>
+        </p:txBody>
+      </p:sp>
+      <p:sp>
+        <p:nvSpPr>
+          <p:cNvPr id="8" name="Text 6"/>
+          <p:cNvSpPr/>
+          <p:nvPr/>
+        </p:nvSpPr>
+        <p:spPr>
+          <a:xfrm>
+            <a:off x="457200" y="4480560"/>
+            <a:ext cx="1828800" cy="274320"/>
+          </a:xfrm>
+          <a:prstGeom prst="rect">
+            <a:avLst/>
+          </a:prstGeom>
+          <a:solidFill>
+            <a:srgbClr val="D9E6D4"/>
+          </a:solidFill>
+          <a:ln/>
+        </p:spPr>
+        <p:txBody>
+          <a:bodyPr wrap="square" rtlCol="0" anchor="ctr"/>
+          <a:lstStyle/>
+          <a:p>
+            <a:pPr marL="0" indent="0" algn="ctr">
+              <a:buNone/>
+            </a:pPr>
+            <a:r>
+              <a:rPr lang="en-US" sz="1100" b="1" dirty="0">
+                <a:solidFill>
+                  <a:srgbClr val="1A1A1A"/>
+                </a:solidFill>
+                <a:latin typeface="Calibri" pitchFamily="34" charset="0"/>
+                <a:ea typeface="Calibri" pitchFamily="34" charset="-122"/>
+                <a:cs typeface="Calibri" pitchFamily="34" charset="-120"/>
+              </a:rPr>
+              <a:t>Getting the angle from the real model, not the docs</a:t>
+            </a:r>
+            <a:endParaRPr lang="en-US" sz="1100" dirty="0"/>
+          </a:p>
+        </p:txBody>
+      </p:sp>
+      <p:sp>
+        <p:nvSpPr>
+          <p:cNvPr id="9" name="Text 7"/>
+          <p:cNvSpPr/>
+          <p:nvPr/>
+        </p:nvSpPr>
+        <p:spPr>
+          <a:xfrm>
+            <a:off x="457200" y="4846320"/>
+            <a:ext cx="6858000" cy="1188720"/>
+          </a:xfrm>
+          <a:prstGeom prst="rect">
+            <a:avLst/>
+          </a:prstGeom>
+          <a:noFill/>
+          <a:ln/>
+        </p:spPr>
+        <p:txBody>
+          <a:bodyPr wrap="square" rtlCol="0" anchor="t"/>
+          <a:lstStyle/>
+          <a:p>
+            <a:pPr marL="0" indent="0">
+              <a:lnSpc>
+                <a:spcPct val="112000"/>
+              </a:lnSpc>
+              <a:buNone/>
+            </a:pPr>
+            <a:r>
+              <a:rPr lang="en-US" sz="1250" b="1" dirty="0">
+                <a:solidFill>
+                  <a:srgbClr val="1A1A1A"/>
+                </a:solidFill>
+                <a:latin typeface="Calibri" pitchFamily="34" charset="0"/>
+                <a:ea typeface="Calibri" pitchFamily="34" charset="-122"/>
+                <a:cs typeface="Calibri" pitchFamily="34" charset="-120"/>
+              </a:rPr>
+              <a:t>The socket has to tilt so the servo's steering axis comes out perfectly vertical even though the rocker/bogie arm it sits on is angled. I stopped trusting my old notes and computed the real angle straight from the live Fusion assembly (walking occurrence.transform2 chains): 30deg at the front/rocker corner, 10deg at the rear/bogie corner.</a:t>
+            </a:r>
+            <a:endParaRPr lang="en-US" sz="1250" dirty="0"/>
+          </a:p>
+        </p:txBody>
+      </p:sp>
+      <p:sp>
+        <p:nvSpPr>
+          <p:cNvPr id="10" name="Shape 8"/>
+          <p:cNvSpPr/>
+          <p:nvPr/>
+        </p:nvSpPr>
+        <p:spPr>
+          <a:xfrm>
+            <a:off x="457200" y="6172200"/>
+            <a:ext cx="6858000" cy="1188720"/>
+          </a:xfrm>
+          <a:prstGeom prst="rect">
+            <a:avLst/>
+          </a:prstGeom>
+          <a:solidFill>
+            <a:srgbClr val="D9E6D4"/>
+          </a:solidFill>
+          <a:ln w="6350">
+            <a:solidFill>
+              <a:srgbClr val="AAAAAA"/>
+            </a:solidFill>
+            <a:prstDash val="solid"/>
+          </a:ln>
+        </p:spPr>
+        <p:txBody>
+          <a:bodyPr/>
+          <a:lstStyle/>
+          <a:p>
+            <a:endParaRPr lang="es-CO"/>
+          </a:p>
+        </p:txBody>
+      </p:sp>
+      <p:sp>
+        <p:nvSpPr>
+          <p:cNvPr id="11" name="Text 9"/>
+          <p:cNvSpPr/>
+          <p:nvPr/>
+        </p:nvSpPr>
+        <p:spPr>
+          <a:xfrm>
+            <a:off x="548640" y="6245352"/>
+            <a:ext cx="6675120" cy="1042416"/>
+          </a:xfrm>
+          <a:prstGeom prst="rect">
+            <a:avLst/>
+          </a:prstGeom>
+          <a:noFill/>
+          <a:ln/>
+        </p:spPr>
+        <p:txBody>
+          <a:bodyPr wrap="square" rtlCol="0" anchor="t"/>
+          <a:lstStyle/>
+          <a:p>
+            <a:pPr marL="0" indent="0">
+              <a:buNone/>
+            </a:pPr>
+            <a:endParaRPr lang="en-US" sz="1000" dirty="0"/>
+            <a:r>
+              <a:rPr lang="en-US" sz="1000" b="1" dirty="0">
+                <a:solidFill>
+                  <a:srgbClr val="1A1A1A"/>
+                </a:solidFill>
+                <a:latin typeface="Calibri" pitchFamily="34" charset="0"/>
+                <a:ea typeface="Calibri" pitchFamily="34" charset="-122"/>
+                <a:cs typeface="Calibri" pitchFamily="34" charset="-120"/>
+              </a:rPr>
+              <a:t>Mirrored for the other side
+</a:t>
+            </a:r>
+            <a:r>
+              <a:rPr lang="en-US" sz="900" dirty="0">
+                <a:solidFill>
+                  <a:srgbClr val="1A1A1A"/>
+                </a:solidFill>
+                <a:latin typeface="Calibri" pitchFamily="34" charset="0"/>
+                <a:ea typeface="Calibri" pitchFamily="34" charset="-122"/>
+                <a:cs typeface="Calibri" pitchFamily="34" charset="-120"/>
+              </a:rPr>
+              <a:t>Once the geometry was right on one side, I mirrored all three knuckle variants (JuntaLlanta, JuntaLlantaEstatica, JuntaLlantaDireccion) across the chassis plane and saved them as their own files (...I suffix) - so the 6-wheel layout is properly symmetric instead of hand-copied angles.</a:t>
+            </a:r>
+          </a:p>
+        </p:txBody>
+      </p:sp>
+      <p:sp>
+        <p:nvSpPr>
+          <p:cNvPr id="14" name="Shape 12"/>
+          <p:cNvSpPr/>
+          <p:nvPr/>
+        </p:nvSpPr>
+        <p:spPr>
+          <a:xfrm>
+            <a:off x="457200" y="9464040"/>
+            <a:ext cx="6858000" cy="0"/>
+          </a:xfrm>
+          <a:prstGeom prst="line">
+            <a:avLst/>
+          </a:prstGeom>
+          <a:noFill/>
+          <a:ln w="9525">
+            <a:solidFill>
+              <a:srgbClr val="1A1A1A"/>
+            </a:solidFill>
+            <a:prstDash val="solid"/>
+          </a:ln>
+        </p:spPr>
+        <p:txBody>
+          <a:bodyPr/>
+          <a:lstStyle/>
+          <a:p>
+            <a:endParaRPr lang="es-CO"/>
+          </a:p>
+        </p:txBody>
+      </p:sp>
+      <p:sp>
+        <p:nvSpPr>
+          <p:cNvPr id="15" name="Text 13"/>
+          <p:cNvSpPr/>
+          <p:nvPr/>
+        </p:nvSpPr>
+        <p:spPr>
+          <a:xfrm>
+            <a:off x="457200" y="9509760"/>
+            <a:ext cx="4572000" cy="228600"/>
+          </a:xfrm>
+          <a:prstGeom prst="rect">
+            <a:avLst/>
+          </a:prstGeom>
+          <a:noFill/>
+          <a:ln/>
+        </p:spPr>
+        <p:txBody>
+          <a:bodyPr wrap="square" rtlCol="0" anchor="ctr"/>
+          <a:lstStyle/>
+          <a:p>
+            <a:pPr marL="0" indent="0">
+              <a:buNone/>
+            </a:pPr>
+            <a:r>
+              <a:rPr lang="en-US" sz="900" b="1" dirty="0">
+                <a:solidFill>
+                  <a:srgbClr val="1A1A1A"/>
+                </a:solidFill>
+                <a:latin typeface="Calibri" pitchFamily="34" charset="0"/>
+                <a:ea typeface="Calibri" pitchFamily="34" charset="-122"/>
+                <a:cs typeface="Calibri" pitchFamily="34" charset="-120"/>
+              </a:rPr>
+              <a:t>Project: </a:t>
+            </a:r>
+            <a:r>
+              <a:rPr lang="en-US" sz="900" dirty="0">
+                <a:solidFill>
+                  <a:srgbClr val="1A1A1A"/>
+                </a:solidFill>
+                <a:latin typeface="Calibri" pitchFamily="34" charset="0"/>
+                <a:ea typeface="Calibri" pitchFamily="34" charset="-122"/>
+                <a:cs typeface="Calibri" pitchFamily="34" charset="-120"/>
+              </a:rPr>
+              <a:t>ROVER "Target Fidelity"</a:t>
+            </a:r>
+            <a:endParaRPr lang="en-US" sz="900" dirty="0"/>
+          </a:p>
+        </p:txBody>
+      </p:sp>
+      <p:sp>
+        <p:nvSpPr>
+          <p:cNvPr id="16" name="Text 14"/>
+          <p:cNvSpPr/>
+          <p:nvPr/>
+        </p:nvSpPr>
+        <p:spPr>
+          <a:xfrm>
+            <a:off x="457200" y="9710928"/>
+            <a:ext cx="3200400" cy="228600"/>
+          </a:xfrm>
+          <a:prstGeom prst="rect">
+            <a:avLst/>
+          </a:prstGeom>
+          <a:noFill/>
+          <a:ln/>
+        </p:spPr>
+        <p:txBody>
+          <a:bodyPr wrap="square" rtlCol="0" anchor="ctr"/>
+          <a:lstStyle/>
+          <a:p>
+            <a:pPr marL="0" indent="0">
+              <a:buNone/>
+            </a:pPr>
+            <a:r>
+              <a:rPr lang="en-US" sz="900" b="1" dirty="0">
+                <a:solidFill>
+                  <a:srgbClr val="1A1A1A"/>
+                </a:solidFill>
+                <a:latin typeface="Calibri" pitchFamily="34" charset="0"/>
+                <a:ea typeface="Calibri" pitchFamily="34" charset="-122"/>
+                <a:cs typeface="Calibri" pitchFamily="34" charset="-120"/>
+              </a:rPr>
+              <a:t>Name: </a:t>
+            </a:r>
+            <a:r>
+              <a:rPr lang="en-US" sz="900" dirty="0">
+                <a:solidFill>
+                  <a:srgbClr val="1A1A1A"/>
+                </a:solidFill>
+                <a:latin typeface="Calibri" pitchFamily="34" charset="0"/>
+                <a:ea typeface="Calibri" pitchFamily="34" charset="-122"/>
+                <a:cs typeface="Calibri" pitchFamily="34" charset="-120"/>
+              </a:rPr>
+              <a:t>SEBDev</a:t>
+            </a:r>
+            <a:endParaRPr lang="en-US" sz="900" dirty="0"/>
+          </a:p>
+        </p:txBody>
+      </p:sp>
+      <p:sp>
+        <p:nvSpPr>
+          <p:cNvPr id="17" name="Text 15"/>
+          <p:cNvSpPr/>
+          <p:nvPr/>
+        </p:nvSpPr>
+        <p:spPr>
+          <a:xfrm>
+            <a:off x="4572000" y="9710928"/>
+            <a:ext cx="1828800" cy="228600"/>
+          </a:xfrm>
+          <a:prstGeom prst="rect">
+            <a:avLst/>
+          </a:prstGeom>
+          <a:noFill/>
+          <a:ln/>
+        </p:spPr>
+        <p:txBody>
+          <a:bodyPr wrap="square" rtlCol="0" anchor="ctr"/>
+          <a:lstStyle/>
+          <a:p>
+            <a:pPr marL="0" indent="0">
+              <a:buNone/>
+            </a:pPr>
+            <a:r>
+              <a:rPr lang="en-US" sz="900" b="1" dirty="0">
+                <a:solidFill>
+                  <a:srgbClr val="1A1A1A"/>
+                </a:solidFill>
+                <a:latin typeface="Calibri" pitchFamily="34" charset="0"/>
+                <a:ea typeface="Calibri" pitchFamily="34" charset="-122"/>
+                <a:cs typeface="Calibri" pitchFamily="34" charset="-120"/>
+              </a:rPr>
+              <a:t>Date: </a:t>
+            </a:r>
+            <a:r>
+              <a:rPr lang="en-US" sz="900" dirty="0">
+                <a:solidFill>
+                  <a:srgbClr val="1A1A1A"/>
+                </a:solidFill>
+                <a:latin typeface="Calibri" pitchFamily="34" charset="0"/>
+                <a:ea typeface="Calibri" pitchFamily="34" charset="-122"/>
+                <a:cs typeface="Calibri" pitchFamily="34" charset="-120"/>
+              </a:rPr>
+              <a:t>08/09/2026</a:t>
+            </a:r>
+            <a:endParaRPr lang="en-US" sz="900" dirty="0"/>
+          </a:p>
+        </p:txBody>
+      </p:sp>
+      <p:sp>
+        <p:nvSpPr>
+          <p:cNvPr id="18" name="Text 16"/>
+          <p:cNvSpPr/>
+          <p:nvPr/>
+        </p:nvSpPr>
+        <p:spPr>
+          <a:xfrm>
+            <a:off x="6400800" y="9710928"/>
+            <a:ext cx="914400" cy="228600"/>
+          </a:xfrm>
+          <a:prstGeom prst="rect">
+            <a:avLst/>
+          </a:prstGeom>
+          <a:noFill/>
+          <a:ln/>
+        </p:spPr>
+        <p:txBody>
+          <a:bodyPr wrap="square" rtlCol="0" anchor="ctr"/>
+          <a:lstStyle/>
+          <a:p>
+            <a:pPr marL="0" indent="0" algn="r">
+              <a:buNone/>
+            </a:pPr>
+            <a:r>
+              <a:rPr lang="en-US" sz="900" dirty="0">
+                <a:solidFill>
+                  <a:srgbClr val="1A1A1A"/>
+                </a:solidFill>
+                <a:latin typeface="Calibri" pitchFamily="34" charset="0"/>
+                <a:ea typeface="Calibri" pitchFamily="34" charset="-122"/>
+                <a:cs typeface="Calibri" pitchFamily="34" charset="-120"/>
+              </a:rPr>
+              <a:t>Page 16</a:t>
+            </a:r>
+            <a:endParaRPr lang="en-US" sz="900" dirty="0"/>
+          </a:p>
+        </p:txBody>
+      </p:sp>
+      <p:pic>
+        <p:nvPicPr>
+          <p:cNvPr id="19" name="Picture 18" descr="junta_llanta_direccion.png"/>
+          <p:cNvPicPr>
+            <a:picLocks noChangeAspect="1"/>
+          </p:cNvPicPr>
+          <p:nvPr/>
+        </p:nvPicPr>
+        <p:blipFill>
+          <a:blip r:embed="rId2"/>
+          <a:stretch>
+            <a:fillRect/>
+          </a:stretch>
+        </p:blipFill>
+        <p:spPr>
+          <a:xfrm>
+            <a:off x="2586200" y="7450000"/>
+            <a:ext cx="2600000" cy="1950000"/>
+          </a:xfrm>
+          <a:prstGeom prst="rect">
+            <a:avLst/>
+          </a:prstGeom>
+        </p:spPr>
+      </p:pic>
+    </p:spTree>
+  </p:cSld>
+  <p:clrMapOvr>
+    <a:masterClrMapping/>
+  </p:clrMapOvr>
+</p:sld>
+</file>
+
+<file path=ppt/slides/slide17.xml><?xml version="1.0" encoding="utf-8"?>
+<p:sld xmlns:a="http://schemas.openxmlformats.org/drawingml/2006/main" xmlns:p="http://schemas.openxmlformats.org/presentationml/2006/main" xmlns:r="http://schemas.openxmlformats.org/officeDocument/2006/relationships">
+  <p:cSld>
+    <p:spTree>
+      <p:nvGrpSpPr>
+        <p:cNvPr id="1" name=""/>
+        <p:cNvGrpSpPr/>
+        <p:nvPr/>
+      </p:nvGrpSpPr>
+      <p:grpSpPr/>
+      <p:sp>
+        <p:nvSpPr>
+          <p:cNvPr id="2" name="Shape 0"/>
+          <p:cNvSpPr/>
+          <p:nvPr/>
+        </p:nvSpPr>
+        <p:spPr>
+          <a:xfrm>
+            <a:off x="457200" y="457200"/>
+            <a:ext cx="6858000" cy="457200"/>
+          </a:xfrm>
+          <a:prstGeom prst="rect">
+            <a:avLst/>
+          </a:prstGeom>
+          <a:solidFill>
+            <a:srgbClr val="A6192E"/>
+          </a:solidFill>
+          <a:ln/>
+        </p:spPr>
+        <p:txBody>
+          <a:bodyPr/>
+          <a:lstStyle/>
+          <a:p>
+            <a:endParaRPr lang="es-CO"/>
+          </a:p>
+        </p:txBody>
+      </p:sp>
+      <p:sp>
+        <p:nvSpPr>
+          <p:cNvPr id="3" name="Text 1"/>
+          <p:cNvSpPr/>
+          <p:nvPr/>
+        </p:nvSpPr>
+        <p:spPr>
+          <a:xfrm>
+            <a:off x="594360" y="457200"/>
+            <a:ext cx="6583680" cy="457200"/>
+          </a:xfrm>
+          <a:prstGeom prst="rect">
+            <a:avLst/>
+          </a:prstGeom>
+          <a:noFill/>
+          <a:ln/>
+        </p:spPr>
+        <p:txBody>
+          <a:bodyPr wrap="square" rtlCol="0" anchor="ctr"/>
+          <a:lstStyle/>
+          <a:p>
+            <a:pPr marL="0" indent="0">
+              <a:buNone/>
+            </a:pPr>
+            <a:r>
+              <a:rPr lang="en-US" sz="1800" b="1" dirty="0">
+                <a:solidFill>
+                  <a:srgbClr val="FFFFFF"/>
+                </a:solidFill>
+                <a:latin typeface="Cambria" pitchFamily="34" charset="0"/>
+                <a:ea typeface="Cambria" pitchFamily="34" charset="-122"/>
+                <a:cs typeface="Cambria" pitchFamily="34" charset="-120"/>
+              </a:rPr>
+              <a:t>Turning the shopping list into a real order</a:t>
+            </a:r>
+            <a:endParaRPr lang="en-US" sz="1800" dirty="0"/>
+          </a:p>
+        </p:txBody>
+      </p:sp>
+      <p:sp>
+        <p:nvSpPr>
+          <p:cNvPr id="4" name="Text 2"/>
+          <p:cNvSpPr/>
+          <p:nvPr/>
+        </p:nvSpPr>
+        <p:spPr>
+          <a:xfrm>
+            <a:off x="457200" y="1097280"/>
+            <a:ext cx="1828800" cy="274320"/>
+          </a:xfrm>
+          <a:prstGeom prst="rect">
+            <a:avLst/>
+          </a:prstGeom>
+          <a:solidFill>
+            <a:srgbClr val="E8929C"/>
+          </a:solidFill>
+          <a:ln/>
+        </p:spPr>
+        <p:txBody>
+          <a:bodyPr wrap="square" rtlCol="0" anchor="ctr"/>
+          <a:lstStyle/>
+          <a:p>
+            <a:pPr marL="0" indent="0" algn="ctr">
+              <a:buNone/>
+            </a:pPr>
+            <a:r>
+              <a:rPr lang="en-US" sz="1100" b="1" dirty="0">
+                <a:solidFill>
+                  <a:srgbClr val="1A1A1A"/>
+                </a:solidFill>
+                <a:latin typeface="Calibri" pitchFamily="34" charset="0"/>
+                <a:ea typeface="Calibri" pitchFamily="34" charset="-122"/>
+                <a:cs typeface="Calibri" pitchFamily="34" charset="-120"/>
+              </a:rPr>
+              <a:t>What actually got bought</a:t>
+            </a:r>
+            <a:endParaRPr lang="en-US" sz="1100" dirty="0"/>
+          </a:p>
+        </p:txBody>
+      </p:sp>
+      <p:sp>
+        <p:nvSpPr>
+          <p:cNvPr id="5" name="Text 3"/>
+          <p:cNvSpPr/>
+          <p:nvPr/>
+        </p:nvSpPr>
+        <p:spPr>
+          <a:xfrm>
+            <a:off x="457200" y="1463040"/>
+            <a:ext cx="6858000" cy="1097280"/>
+          </a:xfrm>
+          <a:prstGeom prst="rect">
+            <a:avLst/>
+          </a:prstGeom>
+          <a:noFill/>
+          <a:ln/>
+        </p:spPr>
+        <p:txBody>
+          <a:bodyPr wrap="square" rtlCol="0" anchor="t"/>
+          <a:lstStyle/>
+          <a:p>
+            <a:pPr marL="0" indent="0">
+              <a:lnSpc>
+                <a:spcPct val="112000"/>
+              </a:lnSpc>
+              <a:buNone/>
+            </a:pPr>
+            <a:r>
+              <a:rPr lang="en-US" sz="1300" dirty="0">
+                <a:solidFill>
+                  <a:srgbClr val="1A1A1A"/>
+                </a:solidFill>
+                <a:latin typeface="Calibri" pitchFamily="34" charset="0"/>
+                <a:ea typeface="Calibri" pitchFamily="34" charset="-122"/>
+                <a:cs typeface="Calibri" pitchFamily="34" charset="-120"/>
+              </a:rPr>
+              <a:t>Placed a real order with I+D Didacticas Electronicas (Pedido S174842, COP $2,216,852 with IVA): all 6 JGB37 motors, 3 BTS7960 drivers, the steering servos, 13m of 2020 aluminum profile, PETG/TPU filament, and more. Updated bom_rover.csv line by line against the invoice - quantities and prices that were estimates before are now marked "Comprado" with the real numbers.</a:t>
+            </a:r>
+            <a:endParaRPr lang="en-US" sz="1300" dirty="0"/>
+          </a:p>
+        </p:txBody>
+      </p:sp>
+      <p:sp>
+        <p:nvSpPr>
+          <p:cNvPr id="6" name="Text 4"/>
+          <p:cNvSpPr/>
+          <p:nvPr/>
+        </p:nvSpPr>
+        <p:spPr>
+          <a:xfrm>
+            <a:off x="457200" y="2697480"/>
+            <a:ext cx="1828800" cy="274320"/>
+          </a:xfrm>
+          <a:prstGeom prst="rect">
+            <a:avLst/>
+          </a:prstGeom>
+          <a:solidFill>
+            <a:srgbClr val="FCEFA6"/>
+          </a:solidFill>
+          <a:ln/>
+        </p:spPr>
+        <p:txBody>
+          <a:bodyPr wrap="square" rtlCol="0" anchor="ctr"/>
+          <a:lstStyle/>
+          <a:p>
+            <a:pPr marL="0" indent="0" algn="ctr">
+              <a:buNone/>
+            </a:pPr>
+            <a:r>
+              <a:rPr lang="en-US" sz="1100" b="1" dirty="0">
+                <a:solidFill>
+                  <a:srgbClr val="1A1A1A"/>
+                </a:solidFill>
+                <a:latin typeface="Calibri" pitchFamily="34" charset="0"/>
+                <a:ea typeface="Calibri" pitchFamily="34" charset="-122"/>
+                <a:cs typeface="Calibri" pitchFamily="34" charset="-120"/>
+              </a:rPr>
+              <a:t>The encoder question, closed</a:t>
+            </a:r>
+            <a:endParaRPr lang="en-US" sz="1100" dirty="0"/>
+          </a:p>
+        </p:txBody>
+      </p:sp>
+      <p:sp>
+        <p:nvSpPr>
+          <p:cNvPr id="7" name="Text 5"/>
+          <p:cNvSpPr/>
+          <p:nvPr/>
+        </p:nvSpPr>
+        <p:spPr>
+          <a:xfrm>
+            <a:off x="457200" y="3063240"/>
+            <a:ext cx="6858000" cy="1280160"/>
+          </a:xfrm>
+          <a:prstGeom prst="rect">
+            <a:avLst/>
+          </a:prstGeom>
+          <a:noFill/>
+          <a:ln/>
+        </p:spPr>
+        <p:txBody>
+          <a:bodyPr wrap="square" rtlCol="0" anchor="t"/>
+          <a:lstStyle/>
+          <a:p>
+            <a:pPr marL="0" indent="0">
+              <a:lnSpc>
+                <a:spcPct val="112000"/>
+              </a:lnSpc>
+              <a:buNone/>
+            </a:pPr>
+            <a:r>
+              <a:rPr lang="en-US" sz="1250" dirty="0">
+                <a:solidFill>
+                  <a:srgbClr val="1A1A1A"/>
+                </a:solidFill>
+                <a:latin typeface="Calibri" pitchFamily="34" charset="0"/>
+                <a:ea typeface="Calibri" pitchFamily="34" charset="-122"/>
+                <a:cs typeface="Calibri" pitchFamily="34" charset="-120"/>
+              </a:rPr>
+              <a:t>Page 13 left this open: whether I needed the Hall-encoder motor variant for SLAM odometry. Didn't have to chase it down - bought 2x 448 CPR optical encoders sized for the 37mm motor shaft instead, so odometry is solved independent of which JGB37 variant I run.</a:t>
+            </a:r>
+            <a:endParaRPr lang="en-US" sz="1250" dirty="0"/>
+          </a:p>
+        </p:txBody>
+      </p:sp>
+      <p:sp>
+        <p:nvSpPr>
+          <p:cNvPr id="8" name="Text 6"/>
+          <p:cNvSpPr/>
+          <p:nvPr/>
+        </p:nvSpPr>
+        <p:spPr>
+          <a:xfrm>
+            <a:off x="457200" y="4480560"/>
+            <a:ext cx="1828800" cy="274320"/>
+          </a:xfrm>
+          <a:prstGeom prst="rect">
+            <a:avLst/>
+          </a:prstGeom>
+          <a:solidFill>
+            <a:srgbClr val="D9E6D4"/>
+          </a:solidFill>
+          <a:ln/>
+        </p:spPr>
+        <p:txBody>
+          <a:bodyPr wrap="square" rtlCol="0" anchor="ctr"/>
+          <a:lstStyle/>
+          <a:p>
+            <a:pPr marL="0" indent="0" algn="ctr">
+              <a:buNone/>
+            </a:pPr>
+            <a:r>
+              <a:rPr lang="en-US" sz="1100" b="1" dirty="0">
+                <a:solidFill>
+                  <a:srgbClr val="1A1A1A"/>
+                </a:solidFill>
+                <a:latin typeface="Calibri" pitchFamily="34" charset="0"/>
+                <a:ea typeface="Calibri" pitchFamily="34" charset="-122"/>
+                <a:cs typeface="Calibri" pitchFamily="34" charset="-120"/>
+              </a:rPr>
+              <a:t>New brain: one board instead of two</a:t>
+            </a:r>
+            <a:endParaRPr lang="en-US" sz="1100" dirty="0"/>
+          </a:p>
+        </p:txBody>
+      </p:sp>
+      <p:sp>
+        <p:nvSpPr>
+          <p:cNvPr id="9" name="Text 7"/>
+          <p:cNvSpPr/>
+          <p:nvPr/>
+        </p:nvSpPr>
+        <p:spPr>
+          <a:xfrm>
+            <a:off x="457200" y="4846320"/>
+            <a:ext cx="6858000" cy="1188720"/>
+          </a:xfrm>
+          <a:prstGeom prst="rect">
+            <a:avLst/>
+          </a:prstGeom>
+          <a:noFill/>
+          <a:ln/>
+        </p:spPr>
+        <p:txBody>
+          <a:bodyPr wrap="square" rtlCol="0" anchor="t"/>
+          <a:lstStyle/>
+          <a:p>
+            <a:pPr marL="0" indent="0">
+              <a:lnSpc>
+                <a:spcPct val="112000"/>
+              </a:lnSpc>
+              <a:buNone/>
+            </a:pPr>
+            <a:r>
+              <a:rPr lang="en-US" sz="1250" b="1" dirty="0">
+                <a:solidFill>
+                  <a:srgbClr val="1A1A1A"/>
+                </a:solidFill>
+                <a:latin typeface="Calibri" pitchFamily="34" charset="0"/>
+                <a:ea typeface="Calibri" pitchFamily="34" charset="-122"/>
+                <a:cs typeface="Calibri" pitchFamily="34" charset="-120"/>
+              </a:rPr>
+              <a:t>Swapped the planned Raspberry Pi 4 + Arduino R4 pair for a single Arduino UNO Q - 2GB RAM, 16GB eMMC, a Linux-capable Cortex-A53 side plus a realtime Cortex-M33 side on one board. One less board to wire and power, no separate microSD to manage.</a:t>
+            </a:r>
+            <a:endParaRPr lang="en-US" sz="1250" dirty="0"/>
+          </a:p>
+        </p:txBody>
+      </p:sp>
+      <p:sp>
+        <p:nvSpPr>
+          <p:cNvPr id="10" name="Shape 8"/>
+          <p:cNvSpPr/>
+          <p:nvPr/>
+        </p:nvSpPr>
+        <p:spPr>
+          <a:xfrm>
+            <a:off x="457200" y="6172200"/>
+            <a:ext cx="6858000" cy="1188720"/>
+          </a:xfrm>
+          <a:prstGeom prst="rect">
+            <a:avLst/>
+          </a:prstGeom>
+          <a:solidFill>
+            <a:srgbClr val="D9E6D4"/>
+          </a:solidFill>
+          <a:ln w="6350">
+            <a:solidFill>
+              <a:srgbClr val="AAAAAA"/>
+            </a:solidFill>
+            <a:prstDash val="solid"/>
+          </a:ln>
+        </p:spPr>
+        <p:txBody>
+          <a:bodyPr/>
+          <a:lstStyle/>
+          <a:p>
+            <a:endParaRPr lang="es-CO"/>
+          </a:p>
+        </p:txBody>
+      </p:sp>
+      <p:sp>
+        <p:nvSpPr>
+          <p:cNvPr id="11" name="Text 9"/>
+          <p:cNvSpPr/>
+          <p:nvPr/>
+        </p:nvSpPr>
+        <p:spPr>
+          <a:xfrm>
+            <a:off x="548640" y="6245352"/>
+            <a:ext cx="6675120" cy="1042416"/>
+          </a:xfrm>
+          <a:prstGeom prst="rect">
+            <a:avLst/>
+          </a:prstGeom>
+          <a:noFill/>
+          <a:ln/>
+        </p:spPr>
+        <p:txBody>
+          <a:bodyPr wrap="square" rtlCol="0" anchor="t"/>
+          <a:lstStyle/>
+          <a:p>
+            <a:pPr marL="0" indent="0">
+              <a:buNone/>
+            </a:pPr>
+            <a:endParaRPr lang="en-US" sz="1000" dirty="0"/>
+            <a:r>
+              <a:rPr lang="en-US" sz="1000" b="1" dirty="0">
+                <a:solidFill>
+                  <a:srgbClr val="1A1A1A"/>
+                </a:solidFill>
+                <a:latin typeface="Calibri" pitchFamily="34" charset="0"/>
+                <a:ea typeface="Calibri" pitchFamily="34" charset="-122"/>
+                <a:cs typeface="Calibri" pitchFamily="34" charset="-120"/>
+              </a:rPr>
+              <a:t>Still pending
+</a:t>
+            </a:r>
+            <a:r>
+              <a:rPr lang="en-US" sz="900" dirty="0">
+                <a:solidFill>
+                  <a:srgbClr val="1A1A1A"/>
+                </a:solidFill>
+                <a:latin typeface="Calibri" pitchFamily="34" charset="0"/>
+                <a:ea typeface="Calibri" pitchFamily="34" charset="-122"/>
+                <a:cs typeface="Calibri" pitchFamily="34" charset="-120"/>
+              </a:rPr>
+              <a:t>Chassis hardware (round tube, acrylic lid, most of the bolts), the battery + charger, and the lab sensors are still on the "Pendiente" list in the BOM - this order covered movilidad, chasis extrusion, filament, and the brain.</a:t>
+            </a:r>
+          </a:p>
+        </p:txBody>
+      </p:sp>
+      <p:sp>
+        <p:nvSpPr>
+          <p:cNvPr id="14" name="Shape 12"/>
+          <p:cNvSpPr/>
+          <p:nvPr/>
+        </p:nvSpPr>
+        <p:spPr>
+          <a:xfrm>
+            <a:off x="457200" y="9464040"/>
+            <a:ext cx="6858000" cy="0"/>
+          </a:xfrm>
+          <a:prstGeom prst="line">
+            <a:avLst/>
+          </a:prstGeom>
+          <a:noFill/>
+          <a:ln w="9525">
+            <a:solidFill>
+              <a:srgbClr val="1A1A1A"/>
+            </a:solidFill>
+            <a:prstDash val="solid"/>
+          </a:ln>
+        </p:spPr>
+        <p:txBody>
+          <a:bodyPr/>
+          <a:lstStyle/>
+          <a:p>
+            <a:endParaRPr lang="es-CO"/>
+          </a:p>
+        </p:txBody>
+      </p:sp>
+      <p:sp>
+        <p:nvSpPr>
+          <p:cNvPr id="15" name="Text 13"/>
+          <p:cNvSpPr/>
+          <p:nvPr/>
+        </p:nvSpPr>
+        <p:spPr>
+          <a:xfrm>
+            <a:off x="457200" y="9509760"/>
+            <a:ext cx="4572000" cy="228600"/>
+          </a:xfrm>
+          <a:prstGeom prst="rect">
+            <a:avLst/>
+          </a:prstGeom>
+          <a:noFill/>
+          <a:ln/>
+        </p:spPr>
+        <p:txBody>
+          <a:bodyPr wrap="square" rtlCol="0" anchor="ctr"/>
+          <a:lstStyle/>
+          <a:p>
+            <a:pPr marL="0" indent="0">
+              <a:buNone/>
+            </a:pPr>
+            <a:r>
+              <a:rPr lang="en-US" sz="900" b="1" dirty="0">
+                <a:solidFill>
+                  <a:srgbClr val="1A1A1A"/>
+                </a:solidFill>
+                <a:latin typeface="Calibri" pitchFamily="34" charset="0"/>
+                <a:ea typeface="Calibri" pitchFamily="34" charset="-122"/>
+                <a:cs typeface="Calibri" pitchFamily="34" charset="-120"/>
+              </a:rPr>
+              <a:t>Project: </a:t>
+            </a:r>
+            <a:r>
+              <a:rPr lang="en-US" sz="900" dirty="0">
+                <a:solidFill>
+                  <a:srgbClr val="1A1A1A"/>
+                </a:solidFill>
+                <a:latin typeface="Calibri" pitchFamily="34" charset="0"/>
+                <a:ea typeface="Calibri" pitchFamily="34" charset="-122"/>
+                <a:cs typeface="Calibri" pitchFamily="34" charset="-120"/>
+              </a:rPr>
+              <a:t>ROVER "Target Fidelity"</a:t>
+            </a:r>
+            <a:endParaRPr lang="en-US" sz="900" dirty="0"/>
+          </a:p>
+        </p:txBody>
+      </p:sp>
+      <p:sp>
+        <p:nvSpPr>
+          <p:cNvPr id="16" name="Text 14"/>
+          <p:cNvSpPr/>
+          <p:nvPr/>
+        </p:nvSpPr>
+        <p:spPr>
+          <a:xfrm>
+            <a:off x="457200" y="9710928"/>
+            <a:ext cx="3200400" cy="228600"/>
+          </a:xfrm>
+          <a:prstGeom prst="rect">
+            <a:avLst/>
+          </a:prstGeom>
+          <a:noFill/>
+          <a:ln/>
+        </p:spPr>
+        <p:txBody>
+          <a:bodyPr wrap="square" rtlCol="0" anchor="ctr"/>
+          <a:lstStyle/>
+          <a:p>
+            <a:pPr marL="0" indent="0">
+              <a:buNone/>
+            </a:pPr>
+            <a:r>
+              <a:rPr lang="en-US" sz="900" b="1" dirty="0">
+                <a:solidFill>
+                  <a:srgbClr val="1A1A1A"/>
+                </a:solidFill>
+                <a:latin typeface="Calibri" pitchFamily="34" charset="0"/>
+                <a:ea typeface="Calibri" pitchFamily="34" charset="-122"/>
+                <a:cs typeface="Calibri" pitchFamily="34" charset="-120"/>
+              </a:rPr>
+              <a:t>Name: </a:t>
+            </a:r>
+            <a:r>
+              <a:rPr lang="en-US" sz="900" dirty="0">
+                <a:solidFill>
+                  <a:srgbClr val="1A1A1A"/>
+                </a:solidFill>
+                <a:latin typeface="Calibri" pitchFamily="34" charset="0"/>
+                <a:ea typeface="Calibri" pitchFamily="34" charset="-122"/>
+                <a:cs typeface="Calibri" pitchFamily="34" charset="-120"/>
+              </a:rPr>
+              <a:t>SEBDev</a:t>
+            </a:r>
+            <a:endParaRPr lang="en-US" sz="900" dirty="0"/>
+          </a:p>
+        </p:txBody>
+      </p:sp>
+      <p:sp>
+        <p:nvSpPr>
+          <p:cNvPr id="17" name="Text 15"/>
+          <p:cNvSpPr/>
+          <p:nvPr/>
+        </p:nvSpPr>
+        <p:spPr>
+          <a:xfrm>
+            <a:off x="4572000" y="9710928"/>
+            <a:ext cx="1828800" cy="228600"/>
+          </a:xfrm>
+          <a:prstGeom prst="rect">
+            <a:avLst/>
+          </a:prstGeom>
+          <a:noFill/>
+          <a:ln/>
+        </p:spPr>
+        <p:txBody>
+          <a:bodyPr wrap="square" rtlCol="0" anchor="ctr"/>
+          <a:lstStyle/>
+          <a:p>
+            <a:pPr marL="0" indent="0">
+              <a:buNone/>
+            </a:pPr>
+            <a:r>
+              <a:rPr lang="en-US" sz="900" b="1" dirty="0">
+                <a:solidFill>
+                  <a:srgbClr val="1A1A1A"/>
+                </a:solidFill>
+                <a:latin typeface="Calibri" pitchFamily="34" charset="0"/>
+                <a:ea typeface="Calibri" pitchFamily="34" charset="-122"/>
+                <a:cs typeface="Calibri" pitchFamily="34" charset="-120"/>
+              </a:rPr>
+              <a:t>Date: </a:t>
+            </a:r>
+            <a:r>
+              <a:rPr lang="en-US" sz="900" dirty="0">
+                <a:solidFill>
+                  <a:srgbClr val="1A1A1A"/>
+                </a:solidFill>
+                <a:latin typeface="Calibri" pitchFamily="34" charset="0"/>
+                <a:ea typeface="Calibri" pitchFamily="34" charset="-122"/>
+                <a:cs typeface="Calibri" pitchFamily="34" charset="-120"/>
+              </a:rPr>
+              <a:t>08/09/2026</a:t>
+            </a:r>
+            <a:endParaRPr lang="en-US" sz="900" dirty="0"/>
+          </a:p>
+        </p:txBody>
+      </p:sp>
+      <p:sp>
+        <p:nvSpPr>
+          <p:cNvPr id="18" name="Text 16"/>
+          <p:cNvSpPr/>
+          <p:nvPr/>
+        </p:nvSpPr>
+        <p:spPr>
+          <a:xfrm>
+            <a:off x="6400800" y="9710928"/>
+            <a:ext cx="914400" cy="228600"/>
+          </a:xfrm>
+          <a:prstGeom prst="rect">
+            <a:avLst/>
+          </a:prstGeom>
+          <a:noFill/>
+          <a:ln/>
+        </p:spPr>
+        <p:txBody>
+          <a:bodyPr wrap="square" rtlCol="0" anchor="ctr"/>
+          <a:lstStyle/>
+          <a:p>
+            <a:pPr marL="0" indent="0" algn="r">
+              <a:buNone/>
+            </a:pPr>
+            <a:r>
+              <a:rPr lang="en-US" sz="900" dirty="0">
+                <a:solidFill>
+                  <a:srgbClr val="1A1A1A"/>
+                </a:solidFill>
+                <a:latin typeface="Calibri" pitchFamily="34" charset="0"/>
+                <a:ea typeface="Calibri" pitchFamily="34" charset="-122"/>
+                <a:cs typeface="Calibri" pitchFamily="34" charset="-120"/>
+              </a:rPr>
+              <a:t>Page 17</a:t>
+            </a:r>
+            <a:endParaRPr lang="en-US" sz="900" dirty="0"/>
+          </a:p>
+        </p:txBody>
+      </p:sp>
+      <p:pic>
+        <p:nvPicPr>
+          <p:cNvPr id="19" name="Picture 18" descr="ensamble_llanta_largo.png"/>
+          <p:cNvPicPr>
+            <a:picLocks noChangeAspect="1"/>
+          </p:cNvPicPr>
+          <p:nvPr/>
+        </p:nvPicPr>
+        <p:blipFill>
+          <a:blip r:embed="rId2"/>
+          <a:stretch>
+            <a:fillRect/>
+          </a:stretch>
+        </p:blipFill>
+        <p:spPr>
+          <a:xfrm>
+            <a:off x="2586200" y="7450000"/>
+            <a:ext cx="2600000" cy="1950000"/>
+          </a:xfrm>
+          <a:prstGeom prst="rect">
+            <a:avLst/>
+          </a:prstGeom>
+        </p:spPr>
+      </p:pic>
+    </p:spTree>
+  </p:cSld>
+  <p:clrMapOvr>
+    <a:masterClrMapping/>
+  </p:clrMapOvr>
+</p:sld>
+</file>
+
+<file path=ppt/slides/slide18.xml><?xml version="1.0" encoding="utf-8"?>
+<p:sld xmlns:a="http://schemas.openxmlformats.org/drawingml/2006/main" xmlns:p="http://schemas.openxmlformats.org/presentationml/2006/main" xmlns:r="http://schemas.openxmlformats.org/officeDocument/2006/relationships">
+  <p:cSld>
+    <p:spTree>
+      <p:nvGrpSpPr>
+        <p:cNvPr id="1" name=""/>
+        <p:cNvGrpSpPr/>
+        <p:nvPr/>
+      </p:nvGrpSpPr>
+      <p:grpSpPr/>
+      <p:sp>
+        <p:nvSpPr>
+          <p:cNvPr id="2" name="Shape 0"/>
+          <p:cNvSpPr/>
+          <p:nvPr/>
+        </p:nvSpPr>
+        <p:spPr>
+          <a:xfrm>
+            <a:off x="457200" y="457200"/>
+            <a:ext cx="6858000" cy="457200"/>
+          </a:xfrm>
+          <a:prstGeom prst="rect">
+            <a:avLst/>
+          </a:prstGeom>
+          <a:solidFill>
+            <a:srgbClr val="A6192E"/>
+          </a:solidFill>
+          <a:ln/>
+        </p:spPr>
+        <p:txBody>
+          <a:bodyPr/>
+          <a:lstStyle/>
+          <a:p>
+            <a:endParaRPr lang="es-CO"/>
+          </a:p>
+        </p:txBody>
+      </p:sp>
+      <p:sp>
+        <p:nvSpPr>
+          <p:cNvPr id="3" name="Text 1"/>
+          <p:cNvSpPr/>
+          <p:nvPr/>
+        </p:nvSpPr>
+        <p:spPr>
+          <a:xfrm>
+            <a:off x="594360" y="457200"/>
+            <a:ext cx="6583680" cy="457200"/>
+          </a:xfrm>
+          <a:prstGeom prst="rect">
+            <a:avLst/>
+          </a:prstGeom>
+          <a:noFill/>
+          <a:ln/>
+        </p:spPr>
+        <p:txBody>
+          <a:bodyPr wrap="square" rtlCol="0" anchor="ctr"/>
+          <a:lstStyle/>
+          <a:p>
+            <a:pPr marL="0" indent="0">
+              <a:buNone/>
+            </a:pPr>
+            <a:r>
+              <a:rPr lang="en-US" sz="1800" b="1" dirty="0">
+                <a:solidFill>
+                  <a:srgbClr val="FFFFFF"/>
+                </a:solidFill>
+                <a:latin typeface="Cambria" pitchFamily="34" charset="0"/>
+                <a:ea typeface="Cambria" pitchFamily="34" charset="-122"/>
+                <a:cs typeface="Cambria" pitchFamily="34" charset="-120"/>
+              </a:rPr>
+              <a:t>Where I'm at &amp; what's next</a:t>
+            </a:r>
+            <a:endParaRPr lang="en-US" sz="1800" dirty="0"/>
+          </a:p>
+        </p:txBody>
+      </p:sp>
+      <p:sp>
+        <p:nvSpPr>
+          <p:cNvPr id="4" name="Text 2"/>
+          <p:cNvSpPr/>
+          <p:nvPr/>
+        </p:nvSpPr>
+        <p:spPr>
+          <a:xfrm>
+            <a:off x="457200" y="1097280"/>
+            <a:ext cx="1828800" cy="274320"/>
+          </a:xfrm>
+          <a:prstGeom prst="rect">
+            <a:avLst/>
+          </a:prstGeom>
+          <a:solidFill>
+            <a:srgbClr val="E8929C"/>
+          </a:solidFill>
+          <a:ln/>
+        </p:spPr>
+        <p:txBody>
+          <a:bodyPr wrap="square" rtlCol="0" anchor="ctr"/>
+          <a:lstStyle/>
+          <a:p>
+            <a:pPr marL="0" indent="0" algn="ctr">
+              <a:buNone/>
+            </a:pPr>
+            <a:r>
+              <a:rPr lang="en-US" sz="1100" b="1" dirty="0">
+                <a:solidFill>
+                  <a:srgbClr val="1A1A1A"/>
+                </a:solidFill>
+                <a:latin typeface="Calibri" pitchFamily="34" charset="0"/>
+                <a:ea typeface="Calibri" pitchFamily="34" charset="-122"/>
+                <a:cs typeface="Calibri" pitchFamily="34" charset="-120"/>
+              </a:rPr>
+              <a:t>What's actually built</a:t>
+            </a:r>
+            <a:endParaRPr lang="en-US" sz="1100" dirty="0"/>
+          </a:p>
+        </p:txBody>
+      </p:sp>
+      <p:sp>
+        <p:nvSpPr>
+          <p:cNvPr id="5" name="Text 3"/>
+          <p:cNvSpPr/>
+          <p:nvPr/>
+        </p:nvSpPr>
+        <p:spPr>
+          <a:xfrm>
+            <a:off x="457200" y="1463040"/>
+            <a:ext cx="6858000" cy="1097280"/>
+          </a:xfrm>
+          <a:prstGeom prst="rect">
+            <a:avLst/>
+          </a:prstGeom>
+          <a:noFill/>
+          <a:ln/>
+        </p:spPr>
+        <p:txBody>
+          <a:bodyPr wrap="square" rtlCol="0" anchor="t"/>
+          <a:lstStyle/>
+          <a:p>
+            <a:pPr marL="0" indent="0">
+              <a:lnSpc>
+                <a:spcPct val="112000"/>
+              </a:lnSpc>
+              <a:buNone/>
+            </a:pPr>
+            <a:r>
+              <a:rPr lang="en-US" sz="1300" dirty="0">
+                <a:solidFill>
+                  <a:srgbClr val="1A1A1A"/>
+                </a:solidFill>
+                <a:latin typeface="Calibri" pitchFamily="34" charset="0"/>
+                <a:ea typeface="Calibri" pitchFamily="34" charset="-122"/>
+                <a:cs typeface="Calibri" pitchFamily="34" charset="-120"/>
+              </a:rPr>
+              <a:t>All three wheel-joint variants (JuntaLlanta, JuntaLlantaEstatica, JuntaLlantaDireccion) have their final socket geometry, sized and angled off the real assembly, plus mirrored left-side copies so the 6-wheel layout is symmetric. The steering knuckle carries a printed bearing instead of a bought one, and I validated the mount against a real MG995 servo in a standalone test assembly first.</a:t>
+            </a:r>
+            <a:endParaRPr lang="en-US" sz="1300" dirty="0"/>
+          </a:p>
+        </p:txBody>
+      </p:sp>
+      <p:sp>
+        <p:nvSpPr>
+          <p:cNvPr id="6" name="Text 4"/>
+          <p:cNvSpPr/>
+          <p:nvPr/>
+        </p:nvSpPr>
+        <p:spPr>
+          <a:xfrm>
+            <a:off x="457200" y="2697480"/>
+            <a:ext cx="1828800" cy="274320"/>
+          </a:xfrm>
+          <a:prstGeom prst="rect">
+            <a:avLst/>
+          </a:prstGeom>
+          <a:solidFill>
+            <a:srgbClr val="FCEFA6"/>
+          </a:solidFill>
+          <a:ln/>
+        </p:spPr>
+        <p:txBody>
+          <a:bodyPr wrap="square" rtlCol="0" anchor="ctr"/>
+          <a:lstStyle/>
+          <a:p>
+            <a:pPr marL="0" indent="0" algn="ctr">
+              <a:buNone/>
+            </a:pPr>
+            <a:r>
+              <a:rPr lang="en-US" sz="1100" b="1" dirty="0">
+                <a:solidFill>
+                  <a:srgbClr val="1A1A1A"/>
+                </a:solidFill>
+                <a:latin typeface="Calibri" pitchFamily="34" charset="0"/>
+                <a:ea typeface="Calibri" pitchFamily="34" charset="-122"/>
+                <a:cs typeface="Calibri" pitchFamily="34" charset="-120"/>
+              </a:rPr>
+              <a:t>What's ordered vs. what's still pending</a:t>
+            </a:r>
+            <a:endParaRPr lang="en-US" sz="1100" dirty="0"/>
+          </a:p>
+        </p:txBody>
+      </p:sp>
+      <p:sp>
+        <p:nvSpPr>
+          <p:cNvPr id="7" name="Text 5"/>
+          <p:cNvSpPr/>
+          <p:nvPr/>
+        </p:nvSpPr>
+        <p:spPr>
+          <a:xfrm>
+            <a:off x="457200" y="3063240"/>
+            <a:ext cx="6858000" cy="1280160"/>
+          </a:xfrm>
+          <a:prstGeom prst="rect">
+            <a:avLst/>
+          </a:prstGeom>
+          <a:noFill/>
+          <a:ln/>
+        </p:spPr>
+        <p:txBody>
+          <a:bodyPr wrap="square" rtlCol="0" anchor="t"/>
+          <a:lstStyle/>
+          <a:p>
+            <a:pPr marL="0" indent="0">
+              <a:lnSpc>
+                <a:spcPct val="112000"/>
+              </a:lnSpc>
+              <a:buNone/>
+            </a:pPr>
+            <a:r>
+              <a:rPr lang="en-US" sz="1250" dirty="0">
+                <a:solidFill>
+                  <a:srgbClr val="1A1A1A"/>
+                </a:solidFill>
+                <a:latin typeface="Calibri" pitchFamily="34" charset="0"/>
+                <a:ea typeface="Calibri" pitchFamily="34" charset="-122"/>
+                <a:cs typeface="Calibri" pitchFamily="34" charset="-120"/>
+              </a:rPr>
+              <a:t>Movilidad electronics, chassis extrusion, filament, and the brain are bought (bom_rover.csv, Pedido S174842). Still pending: round tube + steel axle for the differential, the acrylic/MDF lid, the battery + charger, and the lab module hardware (color sensor, pumps, syringe dispenser).</a:t>
+            </a:r>
+            <a:endParaRPr lang="en-US" sz="1250" dirty="0"/>
+          </a:p>
+        </p:txBody>
+      </p:sp>
+      <p:sp>
+        <p:nvSpPr>
+          <p:cNvPr id="8" name="Text 6"/>
+          <p:cNvSpPr/>
+          <p:nvPr/>
+        </p:nvSpPr>
+        <p:spPr>
+          <a:xfrm>
+            <a:off x="457200" y="4480560"/>
+            <a:ext cx="1828800" cy="274320"/>
+          </a:xfrm>
+          <a:prstGeom prst="rect">
+            <a:avLst/>
+          </a:prstGeom>
+          <a:solidFill>
+            <a:srgbClr val="D9E6D4"/>
+          </a:solidFill>
+          <a:ln/>
+        </p:spPr>
+        <p:txBody>
+          <a:bodyPr wrap="square" rtlCol="0" anchor="ctr"/>
+          <a:lstStyle/>
+          <a:p>
+            <a:pPr marL="0" indent="0" algn="ctr">
+              <a:buNone/>
+            </a:pPr>
+            <a:r>
+              <a:rPr lang="en-US" sz="1100" b="1" dirty="0">
+                <a:solidFill>
+                  <a:srgbClr val="1A1A1A"/>
+                </a:solidFill>
+                <a:latin typeface="Calibri" pitchFamily="34" charset="0"/>
+                <a:ea typeface="Calibri" pitchFamily="34" charset="-122"/>
+                <a:cs typeface="Calibri" pitchFamily="34" charset="-120"/>
+              </a:rPr>
+              <a:t>Next up</a:t>
+            </a:r>
+            <a:endParaRPr lang="en-US" sz="1100" dirty="0"/>
+          </a:p>
+        </p:txBody>
+      </p:sp>
+      <p:sp>
+        <p:nvSpPr>
+          <p:cNvPr id="9" name="Text 7"/>
+          <p:cNvSpPr/>
+          <p:nvPr/>
+        </p:nvSpPr>
+        <p:spPr>
+          <a:xfrm>
+            <a:off x="457200" y="4846320"/>
+            <a:ext cx="6858000" cy="1188720"/>
+          </a:xfrm>
+          <a:prstGeom prst="rect">
+            <a:avLst/>
+          </a:prstGeom>
+          <a:noFill/>
+          <a:ln/>
+        </p:spPr>
+        <p:txBody>
+          <a:bodyPr wrap="square" rtlCol="0" anchor="t"/>
+          <a:lstStyle/>
+          <a:p>
+            <a:pPr marL="0" indent="0">
+              <a:lnSpc>
+                <a:spcPct val="112000"/>
+              </a:lnSpc>
+              <a:buNone/>
+            </a:pPr>
+            <a:r>
+              <a:rPr lang="en-US" sz="1250" b="1" dirty="0">
+                <a:solidFill>
+                  <a:srgbClr val="1A1A1A"/>
+                </a:solidFill>
+                <a:latin typeface="Calibri" pitchFamily="34" charset="0"/>
+                <a:ea typeface="Calibri" pitchFamily="34" charset="-122"/>
+                <a:cs typeface="Calibri" pitchFamily="34" charset="-120"/>
+              </a:rPr>
+              <a:t>Finish the 4 remaining wheel-corner assemblies as real linked-component Fusion assemblies (not flattened single-body hacks), using Ensamble llanta / Ensamble llanta Largo as templates. Then close out the differential/balancin hardware and start on the chassis build.</a:t>
+            </a:r>
+            <a:endParaRPr lang="en-US" sz="1250" dirty="0"/>
+          </a:p>
+        </p:txBody>
+      </p:sp>
+      <p:sp>
+        <p:nvSpPr>
+          <p:cNvPr id="10" name="Shape 8"/>
+          <p:cNvSpPr/>
+          <p:nvPr/>
+        </p:nvSpPr>
+        <p:spPr>
+          <a:xfrm>
+            <a:off x="457200" y="6172200"/>
+            <a:ext cx="6858000" cy="1188720"/>
+          </a:xfrm>
+          <a:prstGeom prst="rect">
+            <a:avLst/>
+          </a:prstGeom>
+          <a:solidFill>
+            <a:srgbClr val="D9E6D4"/>
+          </a:solidFill>
+          <a:ln w="6350">
+            <a:solidFill>
+              <a:srgbClr val="AAAAAA"/>
+            </a:solidFill>
+            <a:prstDash val="solid"/>
+          </a:ln>
+        </p:spPr>
+        <p:txBody>
+          <a:bodyPr/>
+          <a:lstStyle/>
+          <a:p>
+            <a:endParaRPr lang="es-CO"/>
+          </a:p>
+        </p:txBody>
+      </p:sp>
+      <p:sp>
+        <p:nvSpPr>
+          <p:cNvPr id="11" name="Text 9"/>
+          <p:cNvSpPr/>
+          <p:nvPr/>
+        </p:nvSpPr>
+        <p:spPr>
+          <a:xfrm>
+            <a:off x="548640" y="6245352"/>
+            <a:ext cx="6675120" cy="1042416"/>
+          </a:xfrm>
+          <a:prstGeom prst="rect">
+            <a:avLst/>
+          </a:prstGeom>
+          <a:noFill/>
+          <a:ln/>
+        </p:spPr>
+        <p:txBody>
+          <a:bodyPr wrap="square" rtlCol="0" anchor="t"/>
+          <a:lstStyle/>
+          <a:p>
+            <a:pPr marL="0" indent="0">
+              <a:buNone/>
+            </a:pPr>
+            <a:endParaRPr lang="en-US" sz="1000" dirty="0"/>
+            <a:r>
+              <a:rPr lang="en-US" sz="1000" b="1" dirty="0">
+                <a:solidFill>
+                  <a:srgbClr val="1A1A1A"/>
+                </a:solidFill>
+                <a:latin typeface="Calibri" pitchFamily="34" charset="0"/>
+                <a:ea typeface="Calibri" pitchFamily="34" charset="-122"/>
+                <a:cs typeface="Calibri" pitchFamily="34" charset="-120"/>
+              </a:rPr>
+              <a:t>A trick worth keeping
+</a:t>
+            </a:r>
+            <a:r>
+              <a:rPr lang="en-US" sz="900" dirty="0">
+                <a:solidFill>
+                  <a:srgbClr val="1A1A1A"/>
+                </a:solidFill>
+                <a:latin typeface="Calibri" pitchFamily="34" charset="0"/>
+                <a:ea typeface="Calibri" pitchFamily="34" charset="-122"/>
+                <a:cs typeface="Calibri" pitchFamily="34" charset="-120"/>
+              </a:rPr>
+              <a:t>For any live-assembly measurement (angles, positions), read it straight from occurrence.transform2 chains in the actual model instead of trusting old notes - the model changes faster than the docs do.</a:t>
+            </a:r>
+          </a:p>
+        </p:txBody>
+      </p:sp>
+      <p:sp>
+        <p:nvSpPr>
+          <p:cNvPr id="14" name="Shape 12"/>
+          <p:cNvSpPr/>
+          <p:nvPr/>
+        </p:nvSpPr>
+        <p:spPr>
+          <a:xfrm>
+            <a:off x="457200" y="9464040"/>
+            <a:ext cx="6858000" cy="0"/>
+          </a:xfrm>
+          <a:prstGeom prst="line">
+            <a:avLst/>
+          </a:prstGeom>
+          <a:noFill/>
+          <a:ln w="9525">
+            <a:solidFill>
+              <a:srgbClr val="1A1A1A"/>
+            </a:solidFill>
+            <a:prstDash val="solid"/>
+          </a:ln>
+        </p:spPr>
+        <p:txBody>
+          <a:bodyPr/>
+          <a:lstStyle/>
+          <a:p>
+            <a:endParaRPr lang="es-CO"/>
+          </a:p>
+        </p:txBody>
+      </p:sp>
+      <p:sp>
+        <p:nvSpPr>
+          <p:cNvPr id="15" name="Text 13"/>
+          <p:cNvSpPr/>
+          <p:nvPr/>
+        </p:nvSpPr>
+        <p:spPr>
+          <a:xfrm>
+            <a:off x="457200" y="9509760"/>
+            <a:ext cx="4572000" cy="228600"/>
+          </a:xfrm>
+          <a:prstGeom prst="rect">
+            <a:avLst/>
+          </a:prstGeom>
+          <a:noFill/>
+          <a:ln/>
+        </p:spPr>
+        <p:txBody>
+          <a:bodyPr wrap="square" rtlCol="0" anchor="ctr"/>
+          <a:lstStyle/>
+          <a:p>
+            <a:pPr marL="0" indent="0">
+              <a:buNone/>
+            </a:pPr>
+            <a:r>
+              <a:rPr lang="en-US" sz="900" b="1" dirty="0">
+                <a:solidFill>
+                  <a:srgbClr val="1A1A1A"/>
+                </a:solidFill>
+                <a:latin typeface="Calibri" pitchFamily="34" charset="0"/>
+                <a:ea typeface="Calibri" pitchFamily="34" charset="-122"/>
+                <a:cs typeface="Calibri" pitchFamily="34" charset="-120"/>
+              </a:rPr>
+              <a:t>Project: </a:t>
+            </a:r>
+            <a:r>
+              <a:rPr lang="en-US" sz="900" dirty="0">
+                <a:solidFill>
+                  <a:srgbClr val="1A1A1A"/>
+                </a:solidFill>
+                <a:latin typeface="Calibri" pitchFamily="34" charset="0"/>
+                <a:ea typeface="Calibri" pitchFamily="34" charset="-122"/>
+                <a:cs typeface="Calibri" pitchFamily="34" charset="-120"/>
+              </a:rPr>
+              <a:t>ROVER "Target Fidelity"</a:t>
+            </a:r>
+            <a:endParaRPr lang="en-US" sz="900" dirty="0"/>
+          </a:p>
+        </p:txBody>
+      </p:sp>
+      <p:sp>
+        <p:nvSpPr>
+          <p:cNvPr id="16" name="Text 14"/>
+          <p:cNvSpPr/>
+          <p:nvPr/>
+        </p:nvSpPr>
+        <p:spPr>
+          <a:xfrm>
+            <a:off x="457200" y="9710928"/>
+            <a:ext cx="3200400" cy="228600"/>
+          </a:xfrm>
+          <a:prstGeom prst="rect">
+            <a:avLst/>
+          </a:prstGeom>
+          <a:noFill/>
+          <a:ln/>
+        </p:spPr>
+        <p:txBody>
+          <a:bodyPr wrap="square" rtlCol="0" anchor="ctr"/>
+          <a:lstStyle/>
+          <a:p>
+            <a:pPr marL="0" indent="0">
+              <a:buNone/>
+            </a:pPr>
+            <a:r>
+              <a:rPr lang="en-US" sz="900" b="1" dirty="0">
+                <a:solidFill>
+                  <a:srgbClr val="1A1A1A"/>
+                </a:solidFill>
+                <a:latin typeface="Calibri" pitchFamily="34" charset="0"/>
+                <a:ea typeface="Calibri" pitchFamily="34" charset="-122"/>
+                <a:cs typeface="Calibri" pitchFamily="34" charset="-120"/>
+              </a:rPr>
+              <a:t>Name: </a:t>
+            </a:r>
+            <a:r>
+              <a:rPr lang="en-US" sz="900" dirty="0">
+                <a:solidFill>
+                  <a:srgbClr val="1A1A1A"/>
+                </a:solidFill>
+                <a:latin typeface="Calibri" pitchFamily="34" charset="0"/>
+                <a:ea typeface="Calibri" pitchFamily="34" charset="-122"/>
+                <a:cs typeface="Calibri" pitchFamily="34" charset="-120"/>
+              </a:rPr>
+              <a:t>SEBDev</a:t>
+            </a:r>
+            <a:endParaRPr lang="en-US" sz="900" dirty="0"/>
+          </a:p>
+        </p:txBody>
+      </p:sp>
+      <p:sp>
+        <p:nvSpPr>
+          <p:cNvPr id="17" name="Text 15"/>
+          <p:cNvSpPr/>
+          <p:nvPr/>
+        </p:nvSpPr>
+        <p:spPr>
+          <a:xfrm>
+            <a:off x="4572000" y="9710928"/>
+            <a:ext cx="1828800" cy="228600"/>
+          </a:xfrm>
+          <a:prstGeom prst="rect">
+            <a:avLst/>
+          </a:prstGeom>
+          <a:noFill/>
+          <a:ln/>
+        </p:spPr>
+        <p:txBody>
+          <a:bodyPr wrap="square" rtlCol="0" anchor="ctr"/>
+          <a:lstStyle/>
+          <a:p>
+            <a:pPr marL="0" indent="0">
+              <a:buNone/>
+            </a:pPr>
+            <a:r>
+              <a:rPr lang="en-US" sz="900" b="1" dirty="0">
+                <a:solidFill>
+                  <a:srgbClr val="1A1A1A"/>
+                </a:solidFill>
+                <a:latin typeface="Calibri" pitchFamily="34" charset="0"/>
+                <a:ea typeface="Calibri" pitchFamily="34" charset="-122"/>
+                <a:cs typeface="Calibri" pitchFamily="34" charset="-120"/>
+              </a:rPr>
+              <a:t>Date: </a:t>
+            </a:r>
+            <a:r>
+              <a:rPr lang="en-US" sz="900" dirty="0">
+                <a:solidFill>
+                  <a:srgbClr val="1A1A1A"/>
+                </a:solidFill>
+                <a:latin typeface="Calibri" pitchFamily="34" charset="0"/>
+                <a:ea typeface="Calibri" pitchFamily="34" charset="-122"/>
+                <a:cs typeface="Calibri" pitchFamily="34" charset="-120"/>
+              </a:rPr>
+              <a:t>08/09/2026</a:t>
+            </a:r>
+            <a:endParaRPr lang="en-US" sz="900" dirty="0"/>
+          </a:p>
+        </p:txBody>
+      </p:sp>
+      <p:sp>
+        <p:nvSpPr>
+          <p:cNvPr id="18" name="Text 16"/>
+          <p:cNvSpPr/>
+          <p:nvPr/>
+        </p:nvSpPr>
+        <p:spPr>
+          <a:xfrm>
+            <a:off x="6400800" y="9710928"/>
+            <a:ext cx="914400" cy="228600"/>
+          </a:xfrm>
+          <a:prstGeom prst="rect">
+            <a:avLst/>
+          </a:prstGeom>
+          <a:noFill/>
+          <a:ln/>
+        </p:spPr>
+        <p:txBody>
+          <a:bodyPr wrap="square" rtlCol="0" anchor="ctr"/>
+          <a:lstStyle/>
+          <a:p>
+            <a:pPr marL="0" indent="0" algn="r">
+              <a:buNone/>
+            </a:pPr>
+            <a:r>
+              <a:rPr lang="en-US" sz="900" dirty="0">
+                <a:solidFill>
+                  <a:srgbClr val="1A1A1A"/>
+                </a:solidFill>
+                <a:latin typeface="Calibri" pitchFamily="34" charset="0"/>
+                <a:ea typeface="Calibri" pitchFamily="34" charset="-122"/>
+                <a:cs typeface="Calibri" pitchFamily="34" charset="-120"/>
+              </a:rPr>
+              <a:t>Page 18</a:t>
+            </a:r>
+            <a:endParaRPr lang="en-US" sz="900" dirty="0"/>
+          </a:p>
+        </p:txBody>
+      </p:sp>
+    </p:spTree>
+  </p:cSld>
+  <p:clrMapOvr>
+    <a:masterClrMapping/>
+  </p:clrMapOvr>
+</p:sld>
+</file>
+
 <file path=ppt/slides/slide2.xml><?xml version="1.0" encoding="utf-8"?>
 <p:sld xmlns:a="http://schemas.openxmlformats.org/drawingml/2006/main" xmlns:r="http://schemas.openxmlformats.org/officeDocument/2006/relationships" xmlns:p="http://schemas.openxmlformats.org/presentationml/2006/main">
   <p:cSld name="Slide 2">
@@ -19443,7 +21399,7 @@
                           <a:ea typeface="Calibri" pitchFamily="34" charset="-122"/>
                           <a:cs typeface="Calibri" pitchFamily="34" charset="-120"/>
                         </a:rPr>
-                        <a:t>Where I'm at &amp; what's next</a:t>
+                        <a:t>Redesigning the wheel joint: bearing + real angles</a:t>
                       </a:r>
                       <a:endParaRPr lang="en-US" sz="1200" dirty="0">
                         <a:latin typeface="Calibri" charset="0"/>
@@ -19508,7 +21464,411 @@
                           <a:ea typeface="Calibri" pitchFamily="34" charset="-122"/>
                           <a:cs typeface="Calibri" pitchFamily="34" charset="-120"/>
                         </a:rPr>
-                        <a:t>06/30/2026</a:t>
+                        <a:t>08/09/2026</a:t>
+                      </a:r>
+                      <a:endParaRPr lang="en-US" sz="1200" dirty="0">
+                        <a:latin typeface="Calibri" charset="0"/>
+                        <a:ea typeface="Calibri" charset="0"/>
+                        <a:cs typeface="Calibri" charset="0"/>
+                      </a:endParaRPr>
+                    </a:p>
+                  </a:txBody>
+                  <a:tcPr anchor="ctr">
+                    <a:lnL w="6350" cap="flat" cmpd="sng" algn="ctr">
+                      <a:solidFill>
+                        <a:srgbClr val="CCCCCC"/>
+                      </a:solidFill>
+                      <a:prstDash val="solid"/>
+                      <a:round/>
+                      <a:headEnd type="none" w="med" len="med"/>
+                      <a:tailEnd type="none" w="med" len="med"/>
+                    </a:lnL>
+                    <a:lnR w="6350" cap="flat" cmpd="sng" algn="ctr">
+                      <a:solidFill>
+                        <a:srgbClr val="CCCCCC"/>
+                      </a:solidFill>
+                      <a:prstDash val="solid"/>
+                      <a:round/>
+                      <a:headEnd type="none" w="med" len="med"/>
+                      <a:tailEnd type="none" w="med" len="med"/>
+                    </a:lnR>
+                    <a:lnT w="6350" cap="flat" cmpd="sng" algn="ctr">
+                      <a:solidFill>
+                        <a:srgbClr val="CCCCCC"/>
+                      </a:solidFill>
+                      <a:prstDash val="solid"/>
+                      <a:round/>
+                      <a:headEnd type="none" w="med" len="med"/>
+                      <a:tailEnd type="none" w="med" len="med"/>
+                    </a:lnT>
+                    <a:lnB w="6350" cap="flat" cmpd="sng" algn="ctr">
+                      <a:solidFill>
+                        <a:srgbClr val="CCCCCC"/>
+                      </a:solidFill>
+                      <a:prstDash val="solid"/>
+                      <a:round/>
+                      <a:headEnd type="none" w="med" len="med"/>
+                      <a:tailEnd type="none" w="med" len="med"/>
+                    </a:lnB>
+                  </a:tcPr>
+                </a:tc>
+                <a:extLst>
+                  <a:ext uri="{0D108BD9-81ED-4DB2-BD59-A6C34878D82A}">
+                    <a16:rowId xmlns:a16="http://schemas.microsoft.com/office/drawing/2014/main" val="10013"/>
+                  </a:ext>
+                </a:extLst>
+              </a:tr>
+              <a:tr h="384048">
+                <a:tc>
+                  <a:txBody>
+                    <a:bodyPr/>
+                    <a:lstStyle/>
+                    <a:p>
+                      <a:pPr marL="0" indent="0">
+                        <a:buNone/>
+                      </a:pPr>
+                      <a:r>
+                        <a:rPr lang="en-US" sz="1200" dirty="0">
+                          <a:solidFill>
+                            <a:srgbClr val="1A1A1A"/>
+                          </a:solidFill>
+                          <a:latin typeface="Calibri" pitchFamily="34" charset="0"/>
+                          <a:ea typeface="Calibri" pitchFamily="34" charset="-122"/>
+                          <a:cs typeface="Calibri" pitchFamily="34" charset="-120"/>
+                        </a:rPr>
+                        <a:t>17</a:t>
+                      </a:r>
+                      <a:endParaRPr lang="en-US" sz="1200" dirty="0">
+                        <a:latin typeface="Calibri" charset="0"/>
+                        <a:ea typeface="Calibri" charset="0"/>
+                        <a:cs typeface="Calibri" charset="0"/>
+                      </a:endParaRPr>
+                    </a:p>
+                  </a:txBody>
+                  <a:tcPr anchor="ctr">
+                    <a:lnL w="6350" cap="flat" cmpd="sng" algn="ctr">
+                      <a:solidFill>
+                        <a:srgbClr val="CCCCCC"/>
+                      </a:solidFill>
+                      <a:prstDash val="solid"/>
+                      <a:round/>
+                      <a:headEnd type="none" w="med" len="med"/>
+                      <a:tailEnd type="none" w="med" len="med"/>
+                    </a:lnL>
+                    <a:lnR w="6350" cap="flat" cmpd="sng" algn="ctr">
+                      <a:solidFill>
+                        <a:srgbClr val="CCCCCC"/>
+                      </a:solidFill>
+                      <a:prstDash val="solid"/>
+                      <a:round/>
+                      <a:headEnd type="none" w="med" len="med"/>
+                      <a:tailEnd type="none" w="med" len="med"/>
+                    </a:lnR>
+                    <a:lnT w="6350" cap="flat" cmpd="sng" algn="ctr">
+                      <a:solidFill>
+                        <a:srgbClr val="CCCCCC"/>
+                      </a:solidFill>
+                      <a:prstDash val="solid"/>
+                      <a:round/>
+                      <a:headEnd type="none" w="med" len="med"/>
+                      <a:tailEnd type="none" w="med" len="med"/>
+                    </a:lnT>
+                    <a:lnB w="6350" cap="flat" cmpd="sng" algn="ctr">
+                      <a:solidFill>
+                        <a:srgbClr val="CCCCCC"/>
+                      </a:solidFill>
+                      <a:prstDash val="solid"/>
+                      <a:round/>
+                      <a:headEnd type="none" w="med" len="med"/>
+                      <a:tailEnd type="none" w="med" len="med"/>
+                    </a:lnB>
+                  </a:tcPr>
+                </a:tc>
+                <a:tc>
+                  <a:txBody>
+                    <a:bodyPr/>
+                    <a:lstStyle/>
+                    <a:p>
+                      <a:pPr marL="0" indent="0">
+                        <a:buNone/>
+                      </a:pPr>
+                      <a:r>
+                        <a:rPr lang="en-US" sz="1200" dirty="0">
+                          <a:solidFill>
+                            <a:srgbClr val="1A1A1A"/>
+                          </a:solidFill>
+                          <a:latin typeface="Calibri" pitchFamily="34" charset="0"/>
+                          <a:ea typeface="Calibri" pitchFamily="34" charset="-122"/>
+                          <a:cs typeface="Calibri" pitchFamily="34" charset="-120"/>
+                        </a:rPr>
+                        <a:t>Turning the shopping list into a real order</a:t>
+                      </a:r>
+                      <a:endParaRPr lang="en-US" sz="1200" dirty="0">
+                        <a:latin typeface="Calibri" charset="0"/>
+                        <a:ea typeface="Calibri" charset="0"/>
+                        <a:cs typeface="Calibri" charset="0"/>
+                      </a:endParaRPr>
+                    </a:p>
+                  </a:txBody>
+                  <a:tcPr anchor="ctr">
+                    <a:lnL w="6350" cap="flat" cmpd="sng" algn="ctr">
+                      <a:solidFill>
+                        <a:srgbClr val="CCCCCC"/>
+                      </a:solidFill>
+                      <a:prstDash val="solid"/>
+                      <a:round/>
+                      <a:headEnd type="none" w="med" len="med"/>
+                      <a:tailEnd type="none" w="med" len="med"/>
+                    </a:lnL>
+                    <a:lnR w="6350" cap="flat" cmpd="sng" algn="ctr">
+                      <a:solidFill>
+                        <a:srgbClr val="CCCCCC"/>
+                      </a:solidFill>
+                      <a:prstDash val="solid"/>
+                      <a:round/>
+                      <a:headEnd type="none" w="med" len="med"/>
+                      <a:tailEnd type="none" w="med" len="med"/>
+                    </a:lnR>
+                    <a:lnT w="6350" cap="flat" cmpd="sng" algn="ctr">
+                      <a:solidFill>
+                        <a:srgbClr val="CCCCCC"/>
+                      </a:solidFill>
+                      <a:prstDash val="solid"/>
+                      <a:round/>
+                      <a:headEnd type="none" w="med" len="med"/>
+                      <a:tailEnd type="none" w="med" len="med"/>
+                    </a:lnT>
+                    <a:lnB w="6350" cap="flat" cmpd="sng" algn="ctr">
+                      <a:solidFill>
+                        <a:srgbClr val="CCCCCC"/>
+                      </a:solidFill>
+                      <a:prstDash val="solid"/>
+                      <a:round/>
+                      <a:headEnd type="none" w="med" len="med"/>
+                      <a:tailEnd type="none" w="med" len="med"/>
+                    </a:lnB>
+                  </a:tcPr>
+                </a:tc>
+                <a:tc>
+                  <a:txBody>
+                    <a:bodyPr/>
+                    <a:lstStyle/>
+                    <a:p>
+                      <a:pPr marL="0" indent="0">
+                        <a:buNone/>
+                      </a:pPr>
+                      <a:r>
+                        <a:rPr lang="en-US" sz="1200" dirty="0">
+                          <a:solidFill>
+                            <a:srgbClr val="1A1A1A"/>
+                          </a:solidFill>
+                          <a:latin typeface="Calibri" pitchFamily="34" charset="0"/>
+                          <a:ea typeface="Calibri" pitchFamily="34" charset="-122"/>
+                          <a:cs typeface="Calibri" pitchFamily="34" charset="-120"/>
+                        </a:rPr>
+                        <a:t>08/09/2026</a:t>
+                      </a:r>
+                      <a:endParaRPr lang="en-US" sz="1200" dirty="0">
+                        <a:latin typeface="Calibri" charset="0"/>
+                        <a:ea typeface="Calibri" charset="0"/>
+                        <a:cs typeface="Calibri" charset="0"/>
+                      </a:endParaRPr>
+                    </a:p>
+                  </a:txBody>
+                  <a:tcPr anchor="ctr">
+                    <a:lnL w="6350" cap="flat" cmpd="sng" algn="ctr">
+                      <a:solidFill>
+                        <a:srgbClr val="CCCCCC"/>
+                      </a:solidFill>
+                      <a:prstDash val="solid"/>
+                      <a:round/>
+                      <a:headEnd type="none" w="med" len="med"/>
+                      <a:tailEnd type="none" w="med" len="med"/>
+                    </a:lnL>
+                    <a:lnR w="6350" cap="flat" cmpd="sng" algn="ctr">
+                      <a:solidFill>
+                        <a:srgbClr val="CCCCCC"/>
+                      </a:solidFill>
+                      <a:prstDash val="solid"/>
+                      <a:round/>
+                      <a:headEnd type="none" w="med" len="med"/>
+                      <a:tailEnd type="none" w="med" len="med"/>
+                    </a:lnR>
+                    <a:lnT w="6350" cap="flat" cmpd="sng" algn="ctr">
+                      <a:solidFill>
+                        <a:srgbClr val="CCCCCC"/>
+                      </a:solidFill>
+                      <a:prstDash val="solid"/>
+                      <a:round/>
+                      <a:headEnd type="none" w="med" len="med"/>
+                      <a:tailEnd type="none" w="med" len="med"/>
+                    </a:lnT>
+                    <a:lnB w="6350" cap="flat" cmpd="sng" algn="ctr">
+                      <a:solidFill>
+                        <a:srgbClr val="CCCCCC"/>
+                      </a:solidFill>
+                      <a:prstDash val="solid"/>
+                      <a:round/>
+                      <a:headEnd type="none" w="med" len="med"/>
+                      <a:tailEnd type="none" w="med" len="med"/>
+                    </a:lnB>
+                  </a:tcPr>
+                </a:tc>
+                <a:extLst>
+                  <a:ext uri="{0D108BD9-81ED-4DB2-BD59-A6C34878D82A}">
+                    <a16:rowId xmlns:a16="http://schemas.microsoft.com/office/drawing/2014/main" val="10013"/>
+                  </a:ext>
+                </a:extLst>
+              </a:tr>
+              <a:tr h="384048">
+                <a:tc>
+                  <a:txBody>
+                    <a:bodyPr/>
+                    <a:lstStyle/>
+                    <a:p>
+                      <a:pPr marL="0" indent="0">
+                        <a:buNone/>
+                      </a:pPr>
+                      <a:r>
+                        <a:rPr lang="en-US" sz="1200" dirty="0">
+                          <a:solidFill>
+                            <a:srgbClr val="1A1A1A"/>
+                          </a:solidFill>
+                          <a:latin typeface="Calibri" pitchFamily="34" charset="0"/>
+                          <a:ea typeface="Calibri" pitchFamily="34" charset="-122"/>
+                          <a:cs typeface="Calibri" pitchFamily="34" charset="-120"/>
+                        </a:rPr>
+                        <a:t>18</a:t>
+                      </a:r>
+                      <a:endParaRPr lang="en-US" sz="1200" dirty="0">
+                        <a:latin typeface="Calibri" charset="0"/>
+                        <a:ea typeface="Calibri" charset="0"/>
+                        <a:cs typeface="Calibri" charset="0"/>
+                      </a:endParaRPr>
+                    </a:p>
+                  </a:txBody>
+                  <a:tcPr anchor="ctr">
+                    <a:lnL w="6350" cap="flat" cmpd="sng" algn="ctr">
+                      <a:solidFill>
+                        <a:srgbClr val="CCCCCC"/>
+                      </a:solidFill>
+                      <a:prstDash val="solid"/>
+                      <a:round/>
+                      <a:headEnd type="none" w="med" len="med"/>
+                      <a:tailEnd type="none" w="med" len="med"/>
+                    </a:lnL>
+                    <a:lnR w="6350" cap="flat" cmpd="sng" algn="ctr">
+                      <a:solidFill>
+                        <a:srgbClr val="CCCCCC"/>
+                      </a:solidFill>
+                      <a:prstDash val="solid"/>
+                      <a:round/>
+                      <a:headEnd type="none" w="med" len="med"/>
+                      <a:tailEnd type="none" w="med" len="med"/>
+                    </a:lnR>
+                    <a:lnT w="6350" cap="flat" cmpd="sng" algn="ctr">
+                      <a:solidFill>
+                        <a:srgbClr val="CCCCCC"/>
+                      </a:solidFill>
+                      <a:prstDash val="solid"/>
+                      <a:round/>
+                      <a:headEnd type="none" w="med" len="med"/>
+                      <a:tailEnd type="none" w="med" len="med"/>
+                    </a:lnT>
+                    <a:lnB w="6350" cap="flat" cmpd="sng" algn="ctr">
+                      <a:solidFill>
+                        <a:srgbClr val="CCCCCC"/>
+                      </a:solidFill>
+                      <a:prstDash val="solid"/>
+                      <a:round/>
+                      <a:headEnd type="none" w="med" len="med"/>
+                      <a:tailEnd type="none" w="med" len="med"/>
+                    </a:lnB>
+                  </a:tcPr>
+                </a:tc>
+                <a:tc>
+                  <a:txBody>
+                    <a:bodyPr/>
+                    <a:lstStyle/>
+                    <a:p>
+                      <a:pPr marL="0" indent="0">
+                        <a:buNone/>
+                      </a:pPr>
+                      <a:r>
+                        <a:rPr lang="en-US" sz="1200" dirty="0">
+                          <a:solidFill>
+                            <a:srgbClr val="1A1A1A"/>
+                          </a:solidFill>
+                          <a:latin typeface="Calibri" pitchFamily="34" charset="0"/>
+                          <a:ea typeface="Calibri" pitchFamily="34" charset="-122"/>
+                          <a:cs typeface="Calibri" pitchFamily="34" charset="-120"/>
+                        </a:rPr>
+                        <a:t>Where I'm at &amp; what's next</a:t>
+                      </a:r>
+                      <a:endParaRPr lang="en-US" sz="1200" dirty="0">
+                        <a:latin typeface="Calibri" charset="0"/>
+                        <a:ea typeface="Calibri" charset="0"/>
+                        <a:cs typeface="Calibri" charset="0"/>
+                      </a:endParaRPr>
+                    </a:p>
+                  </a:txBody>
+                  <a:tcPr anchor="ctr">
+                    <a:lnL w="6350" cap="flat" cmpd="sng" algn="ctr">
+                      <a:solidFill>
+                        <a:srgbClr val="CCCCCC"/>
+                      </a:solidFill>
+                      <a:prstDash val="solid"/>
+                      <a:round/>
+                      <a:headEnd type="none" w="med" len="med"/>
+                      <a:tailEnd type="none" w="med" len="med"/>
+                    </a:lnL>
+                    <a:lnR w="6350" cap="flat" cmpd="sng" algn="ctr">
+                      <a:solidFill>
+                        <a:srgbClr val="CCCCCC"/>
+                      </a:solidFill>
+                      <a:prstDash val="solid"/>
+                      <a:round/>
+                      <a:headEnd type="none" w="med" len="med"/>
+                      <a:tailEnd type="none" w="med" len="med"/>
+                    </a:lnR>
+                    <a:lnT w="6350" cap="flat" cmpd="sng" algn="ctr">
+                      <a:solidFill>
+                        <a:srgbClr val="CCCCCC"/>
+                      </a:solidFill>
+                      <a:prstDash val="solid"/>
+                      <a:round/>
+                      <a:headEnd type="none" w="med" len="med"/>
+                      <a:tailEnd type="none" w="med" len="med"/>
+                    </a:lnT>
+                    <a:lnB w="6350" cap="flat" cmpd="sng" algn="ctr">
+                      <a:solidFill>
+                        <a:srgbClr val="CCCCCC"/>
+                      </a:solidFill>
+                      <a:prstDash val="solid"/>
+                      <a:round/>
+                      <a:headEnd type="none" w="med" len="med"/>
+                      <a:tailEnd type="none" w="med" len="med"/>
+                    </a:lnB>
+                  </a:tcPr>
+                </a:tc>
+                <a:tc>
+                  <a:txBody>
+                    <a:bodyPr/>
+                    <a:lstStyle/>
+                    <a:p>
+                      <a:pPr marL="0" indent="0">
+                        <a:buNone/>
+                      </a:pPr>
+                      <a:r>
+                        <a:rPr lang="en-US" sz="1200" dirty="0">
+                          <a:solidFill>
+                            <a:srgbClr val="1A1A1A"/>
+                          </a:solidFill>
+                          <a:latin typeface="Calibri" pitchFamily="34" charset="0"/>
+                          <a:ea typeface="Calibri" pitchFamily="34" charset="-122"/>
+                          <a:cs typeface="Calibri" pitchFamily="34" charset="-120"/>
+                        </a:rPr>
+                        <a:t>08/09/2026</a:t>
                       </a:r>
                       <a:endParaRPr lang="en-US" sz="1200" dirty="0">
                         <a:latin typeface="Calibri" charset="0"/>

</xml_diff>

<commit_message>
Fix BOM: quote, not a purchase; fill in missing journal images
- The I+D pricing was a quotation (Cotizacion S174842), not a completed
  order - bom_rover.csv, README, and the journal's real-order page now
  say Cotizado/quoted throughout instead of Comprado/bought.
- Fill the 6 empty image placeholders left in the journal (intro hero,
  rocker-bogie arm geometry, printed tube joint x2, motor cavity fit,
  filament/printed-parts) with real Fusion screenshots and renders.
- Journal cover was already a single flattened picture (not editable
  components) - confirmed, no change needed there.
</commit_message>
<xml_diff>
--- a/Journal/Librito_Rover x_x (CreacionSistemaMecanico) .pptx
+++ b/Journal/Librito_Rover x_x (CreacionSistemaMecanico) .pptx
@@ -5,7 +5,7 @@
     <p:sldMasterId id="2147483648" r:id="rId1"/>
   </p:sldMasterIdLst>
   <p:notesMasterIdLst>
-    <p:notesMasterId r:id="rId17"/>
+    <p:notesMasterId r:id="rId20"/>
   </p:notesMasterIdLst>
   <p:sldIdLst>
     <p:sldId id="256" r:id="rId2"/>
@@ -23,9 +23,9 @@
     <p:sldId id="268" r:id="rId14"/>
     <p:sldId id="269" r:id="rId15"/>
     <p:sldId id="270" r:id="rId16"/>
-    <p:sldId id="271" r:id="rId23"/>
-    <p:sldId id="272" r:id="rId24"/>
-    <p:sldId id="273" r:id="rId25"/>
+    <p:sldId id="271" r:id="rId17"/>
+    <p:sldId id="272" r:id="rId18"/>
+    <p:sldId id="273" r:id="rId19"/>
   </p:sldIdLst>
   <p:sldSz cx="7772400" cy="10058400"/>
   <p:notesSz cx="10058400" cy="7772400"/>
@@ -2127,7 +2127,7 @@
         </p:blipFill>
         <p:spPr>
           <a:xfrm>
-            <a:off x="-749300" y="-444500"/>
+            <a:off x="0" y="0"/>
             <a:ext cx="7772400" cy="10058400"/>
           </a:xfrm>
           <a:prstGeom prst="rect">
@@ -10529,6 +10529,30 @@
           </a:p>
         </p:txBody>
       </p:sp>
+      <p:pic>
+        <p:nvPicPr>
+          <p:cNvPr id="20" name="Picture 19" descr="wheel1_joint_p2_motor_mount.png"/>
+          <p:cNvPicPr>
+            <a:picLocks noChangeAspect="1"/>
+          </p:cNvPicPr>
+          <p:nvPr/>
+        </p:nvPicPr>
+        <p:blipFill>
+          <a:blip r:embed="rId3"/>
+          <a:stretch>
+            <a:fillRect/>
+          </a:stretch>
+        </p:blipFill>
+        <p:spPr>
+          <a:xfrm>
+            <a:off x="2862072" y="7772400"/>
+            <a:ext cx="2048255" cy="1463040"/>
+          </a:xfrm>
+          <a:prstGeom prst="rect">
+            <a:avLst/>
+          </a:prstGeom>
+        </p:spPr>
+      </p:pic>
     </p:spTree>
   </p:cSld>
   <p:clrMapOvr>
@@ -16391,6 +16415,30 @@
           </a:p>
         </p:txBody>
       </p:sp>
+      <p:pic>
+        <p:nvPicPr>
+          <p:cNvPr id="17" name="Picture 16" descr="image.png"/>
+          <p:cNvPicPr>
+            <a:picLocks noChangeAspect="1"/>
+          </p:cNvPicPr>
+          <p:nvPr/>
+        </p:nvPicPr>
+        <p:blipFill>
+          <a:blip r:embed="rId3"/>
+          <a:stretch>
+            <a:fillRect/>
+          </a:stretch>
+        </p:blipFill>
+        <p:spPr>
+          <a:xfrm>
+            <a:off x="1734607" y="7726680"/>
+            <a:ext cx="4303185" cy="1508760"/>
+          </a:xfrm>
+          <a:prstGeom prst="rect">
+            <a:avLst/>
+          </a:prstGeom>
+        </p:spPr>
+      </p:pic>
     </p:spTree>
   </p:cSld>
   <p:clrMapOvr>
@@ -16400,7 +16448,7 @@
 </file>
 
 <file path=ppt/slides/slide16.xml><?xml version="1.0" encoding="utf-8"?>
-<p:sld xmlns:a="http://schemas.openxmlformats.org/drawingml/2006/main" xmlns:p="http://schemas.openxmlformats.org/presentationml/2006/main" xmlns:r="http://schemas.openxmlformats.org/officeDocument/2006/relationships">
+<p:sld xmlns:a="http://schemas.openxmlformats.org/drawingml/2006/main" xmlns:r="http://schemas.openxmlformats.org/officeDocument/2006/relationships" xmlns:p="http://schemas.openxmlformats.org/presentationml/2006/main">
   <p:cSld>
     <p:spTree>
       <p:nvGrpSpPr>
@@ -16408,7 +16456,14 @@
         <p:cNvGrpSpPr/>
         <p:nvPr/>
       </p:nvGrpSpPr>
-      <p:grpSpPr/>
+      <p:grpSpPr>
+        <a:xfrm>
+          <a:off x="0" y="0"/>
+          <a:ext cx="0" cy="0"/>
+          <a:chOff x="0" y="0"/>
+          <a:chExt cx="0" cy="0"/>
+        </a:xfrm>
+      </p:grpSpPr>
       <p:sp>
         <p:nvSpPr>
           <p:cNvPr id="2" name="Shape 0"/>
@@ -16780,30 +16835,26 @@
             <a:pPr marL="0" indent="0">
               <a:buNone/>
             </a:pPr>
-            <a:endParaRPr lang="en-US" sz="1000" dirty="0"/>
             <a:r>
-              <a:rPr lang="en-US" sz="1000" b="1" dirty="0">
+              <a:rPr sz="1000" b="1">
                 <a:solidFill>
                   <a:srgbClr val="1A1A1A"/>
                 </a:solidFill>
-                <a:latin typeface="Calibri" pitchFamily="34" charset="0"/>
-                <a:ea typeface="Calibri" pitchFamily="34" charset="-122"/>
-                <a:cs typeface="Calibri" pitchFamily="34" charset="-120"/>
+                <a:latin typeface="Calibri"/>
               </a:rPr>
               <a:t>Mirrored for the other side
 </a:t>
             </a:r>
             <a:r>
-              <a:rPr lang="en-US" sz="900" dirty="0">
+              <a:rPr sz="900" b="0">
                 <a:solidFill>
                   <a:srgbClr val="1A1A1A"/>
                 </a:solidFill>
-                <a:latin typeface="Calibri" pitchFamily="34" charset="0"/>
-                <a:ea typeface="Calibri" pitchFamily="34" charset="-122"/>
-                <a:cs typeface="Calibri" pitchFamily="34" charset="-120"/>
+                <a:latin typeface="Calibri"/>
               </a:rPr>
               <a:t>Once the geometry was right on one side, I mirrored all three knuckle variants (JuntaLlanta, JuntaLlantaEstatica, JuntaLlantaDireccion) across the chassis plane and saved them as their own files (...I suffix) - so the 6-wheel layout is properly symmetric instead of hand-copied angles.</a:t>
             </a:r>
+            <a:endParaRPr lang="en-US" sz="1000" dirty="0"/>
           </a:p>
         </p:txBody>
       </p:sp>
@@ -17059,7 +17110,7 @@
 </file>
 
 <file path=ppt/slides/slide17.xml><?xml version="1.0" encoding="utf-8"?>
-<p:sld xmlns:a="http://schemas.openxmlformats.org/drawingml/2006/main" xmlns:p="http://schemas.openxmlformats.org/presentationml/2006/main" xmlns:r="http://schemas.openxmlformats.org/officeDocument/2006/relationships">
+<p:sld xmlns:a="http://schemas.openxmlformats.org/drawingml/2006/main" xmlns:r="http://schemas.openxmlformats.org/officeDocument/2006/relationships" xmlns:p="http://schemas.openxmlformats.org/presentationml/2006/main">
   <p:cSld>
     <p:spTree>
       <p:nvGrpSpPr>
@@ -17067,7 +17118,14 @@
         <p:cNvGrpSpPr/>
         <p:nvPr/>
       </p:nvGrpSpPr>
-      <p:grpSpPr/>
+      <p:grpSpPr>
+        <a:xfrm>
+          <a:off x="0" y="0"/>
+          <a:ext cx="0" cy="0"/>
+          <a:chOff x="0" y="0"/>
+          <a:chExt cx="0" cy="0"/>
+        </a:xfrm>
+      </p:grpSpPr>
       <p:sp>
         <p:nvSpPr>
           <p:cNvPr id="2" name="Shape 0"/>
@@ -17128,7 +17186,7 @@
                 <a:ea typeface="Cambria" pitchFamily="34" charset="-122"/>
                 <a:cs typeface="Cambria" pitchFamily="34" charset="-120"/>
               </a:rPr>
-              <a:t>Turning the shopping list into a real order</a:t>
+              <a:t>Getting a real quote for the shopping list</a:t>
             </a:r>
             <a:endParaRPr lang="en-US" sz="1800" dirty="0"/>
           </a:p>
@@ -17169,7 +17227,7 @@
                 <a:ea typeface="Calibri" pitchFamily="34" charset="-122"/>
                 <a:cs typeface="Calibri" pitchFamily="34" charset="-120"/>
               </a:rPr>
-              <a:t>What actually got bought</a:t>
+              <a:t>What a real quote actually costs</a:t>
             </a:r>
             <a:endParaRPr lang="en-US" sz="1100" dirty="0"/>
           </a:p>
@@ -17211,7 +17269,7 @@
                 <a:ea typeface="Calibri" pitchFamily="34" charset="-122"/>
                 <a:cs typeface="Calibri" pitchFamily="34" charset="-120"/>
               </a:rPr>
-              <a:t>Placed a real order with I+D Didacticas Electronicas (Pedido S174842, COP $2,216,852 with IVA): all 6 JGB37 motors, 3 BTS7960 drivers, the steering servos, 13m of 2020 aluminum profile, PETG/TPU filament, and more. Updated bom_rover.csv line by line against the invoice - quantities and prices that were estimates before are now marked "Comprado" with the real numbers.</a:t>
+              <a:t>Got a real quote from I+D Didacticas Electronicas (Cotizacion S174842, COP $2,216,852 with IVA) - all 6 JGB37 motors, 3 BTS7960 drivers, the steering servos, 13m of 2020 aluminum profile, PETG/TPU filament, and more, nothing purchased yet. Updated bom_rover.csv line by line against the quote - prices that were rough guesses before are now marked "Cotizado" with the real numbers.</a:t>
             </a:r>
             <a:endParaRPr lang="en-US" sz="1300" dirty="0"/>
           </a:p>
@@ -17439,30 +17497,26 @@
             <a:pPr marL="0" indent="0">
               <a:buNone/>
             </a:pPr>
-            <a:endParaRPr lang="en-US" sz="1000" dirty="0"/>
             <a:r>
-              <a:rPr lang="en-US" sz="1000" b="1" dirty="0">
+              <a:rPr sz="1000" b="1">
                 <a:solidFill>
                   <a:srgbClr val="1A1A1A"/>
                 </a:solidFill>
-                <a:latin typeface="Calibri" pitchFamily="34" charset="0"/>
-                <a:ea typeface="Calibri" pitchFamily="34" charset="-122"/>
-                <a:cs typeface="Calibri" pitchFamily="34" charset="-120"/>
+                <a:latin typeface="Calibri"/>
               </a:rPr>
               <a:t>Still pending
 </a:t>
             </a:r>
             <a:r>
-              <a:rPr lang="en-US" sz="900" dirty="0">
+              <a:rPr sz="900" b="0">
                 <a:solidFill>
                   <a:srgbClr val="1A1A1A"/>
                 </a:solidFill>
-                <a:latin typeface="Calibri" pitchFamily="34" charset="0"/>
-                <a:ea typeface="Calibri" pitchFamily="34" charset="-122"/>
-                <a:cs typeface="Calibri" pitchFamily="34" charset="-120"/>
+                <a:latin typeface="Calibri"/>
               </a:rPr>
-              <a:t>Chassis hardware (round tube, acrylic lid, most of the bolts), the battery + charger, and the lab sensors are still on the "Pendiente" list in the BOM - this order covered movilidad, chasis extrusion, filament, and the brain.</a:t>
+              <a:t>Chassis hardware (round tube, acrylic lid, most of the bolts), the battery + charger, and the lab sensors are still on the "Pendiente" list in the BOM - this quote covers movilidad, chasis extrusion, filament, and the brain, but nothing has actually been ordered yet.</a:t>
             </a:r>
+            <a:endParaRPr lang="en-US" sz="1000" dirty="0"/>
           </a:p>
         </p:txBody>
       </p:sp>
@@ -17718,7 +17772,7 @@
 </file>
 
 <file path=ppt/slides/slide18.xml><?xml version="1.0" encoding="utf-8"?>
-<p:sld xmlns:a="http://schemas.openxmlformats.org/drawingml/2006/main" xmlns:p="http://schemas.openxmlformats.org/presentationml/2006/main" xmlns:r="http://schemas.openxmlformats.org/officeDocument/2006/relationships">
+<p:sld xmlns:a="http://schemas.openxmlformats.org/drawingml/2006/main" xmlns:r="http://schemas.openxmlformats.org/officeDocument/2006/relationships" xmlns:p="http://schemas.openxmlformats.org/presentationml/2006/main">
   <p:cSld>
     <p:spTree>
       <p:nvGrpSpPr>
@@ -17726,7 +17780,14 @@
         <p:cNvGrpSpPr/>
         <p:nvPr/>
       </p:nvGrpSpPr>
-      <p:grpSpPr/>
+      <p:grpSpPr>
+        <a:xfrm>
+          <a:off x="0" y="0"/>
+          <a:ext cx="0" cy="0"/>
+          <a:chOff x="0" y="0"/>
+          <a:chExt cx="0" cy="0"/>
+        </a:xfrm>
+      </p:grpSpPr>
       <p:sp>
         <p:nvSpPr>
           <p:cNvPr id="2" name="Shape 0"/>
@@ -17911,7 +17972,7 @@
                 <a:ea typeface="Calibri" pitchFamily="34" charset="-122"/>
                 <a:cs typeface="Calibri" pitchFamily="34" charset="-120"/>
               </a:rPr>
-              <a:t>What's ordered vs. what's still pending</a:t>
+              <a:t>What's priced vs. still pending</a:t>
             </a:r>
             <a:endParaRPr lang="en-US" sz="1100" dirty="0"/>
           </a:p>
@@ -17953,7 +18014,7 @@
                 <a:ea typeface="Calibri" pitchFamily="34" charset="-122"/>
                 <a:cs typeface="Calibri" pitchFamily="34" charset="-120"/>
               </a:rPr>
-              <a:t>Movilidad electronics, chassis extrusion, filament, and the brain are bought (bom_rover.csv, Pedido S174842). Still pending: round tube + steel axle for the differential, the acrylic/MDF lid, the battery + charger, and the lab module hardware (color sensor, pumps, syringe dispenser).</a:t>
+              <a:t>Movilidad electronics, chassis extrusion, filament, and the brain are priced out in a real quote (bom_rover.csv, Cotizacion S174842) but nothing has been purchased yet. Still pending: round tube + steel axle for the differential, the acrylic/MDF lid, the battery + charger, and the lab module hardware (color sensor, pumps, syringe dispenser).</a:t>
             </a:r>
             <a:endParaRPr lang="en-US" sz="1250" dirty="0"/>
           </a:p>
@@ -18098,30 +18159,26 @@
             <a:pPr marL="0" indent="0">
               <a:buNone/>
             </a:pPr>
-            <a:endParaRPr lang="en-US" sz="1000" dirty="0"/>
             <a:r>
-              <a:rPr lang="en-US" sz="1000" b="1" dirty="0">
+              <a:rPr sz="1000" b="1">
                 <a:solidFill>
                   <a:srgbClr val="1A1A1A"/>
                 </a:solidFill>
-                <a:latin typeface="Calibri" pitchFamily="34" charset="0"/>
-                <a:ea typeface="Calibri" pitchFamily="34" charset="-122"/>
-                <a:cs typeface="Calibri" pitchFamily="34" charset="-120"/>
+                <a:latin typeface="Calibri"/>
               </a:rPr>
               <a:t>A trick worth keeping
 </a:t>
             </a:r>
             <a:r>
-              <a:rPr lang="en-US" sz="900" dirty="0">
+              <a:rPr sz="900" b="0">
                 <a:solidFill>
                   <a:srgbClr val="1A1A1A"/>
                 </a:solidFill>
-                <a:latin typeface="Calibri" pitchFamily="34" charset="0"/>
-                <a:ea typeface="Calibri" pitchFamily="34" charset="-122"/>
-                <a:cs typeface="Calibri" pitchFamily="34" charset="-120"/>
+                <a:latin typeface="Calibri"/>
               </a:rPr>
               <a:t>For any live-assembly measurement (angles, positions), read it straight from occurrence.transform2 chains in the actual model instead of trusting old notes - the model changes faster than the docs do.</a:t>
             </a:r>
+            <a:endParaRPr lang="en-US" sz="1000" dirty="0"/>
           </a:p>
         </p:txBody>
       </p:sp>
@@ -18459,7 +18516,7 @@
         </p:nvGraphicFramePr>
         <p:xfrm>
           <a:off x="457200" y="1188720"/>
-          <a:ext cx="6858000" cy="5760720"/>
+          <a:ext cx="6858000" cy="6528816"/>
         </p:xfrm>
         <a:graphic>
           <a:graphicData uri="http://schemas.openxmlformats.org/drawingml/2006/table">
@@ -21514,7 +21571,7 @@
                 </a:tc>
                 <a:extLst>
                   <a:ext uri="{0D108BD9-81ED-4DB2-BD59-A6C34878D82A}">
-                    <a16:rowId xmlns:a16="http://schemas.microsoft.com/office/drawing/2014/main" val="10013"/>
+                    <a16:rowId xmlns:a16="http://schemas.microsoft.com/office/drawing/2014/main" val="3320666263"/>
                   </a:ext>
                 </a:extLst>
               </a:tr>
@@ -21589,25 +21646,9 @@
                     <a:bodyPr/>
                     <a:lstStyle/>
                     <a:p>
-                      <a:pPr marL="0" indent="0">
-                        <a:buNone/>
-                      </a:pPr>
                       <a:r>
-                        <a:rPr lang="en-US" sz="1200" dirty="0">
-                          <a:solidFill>
-                            <a:srgbClr val="1A1A1A"/>
-                          </a:solidFill>
-                          <a:latin typeface="Calibri" pitchFamily="34" charset="0"/>
-                          <a:ea typeface="Calibri" pitchFamily="34" charset="-122"/>
-                          <a:cs typeface="Calibri" pitchFamily="34" charset="-120"/>
-                        </a:rPr>
-                        <a:t>Turning the shopping list into a real order</a:t>
+                        <a:t>Getting a real quote for the shopping list</a:t>
                       </a:r>
-                      <a:endParaRPr lang="en-US" sz="1200" dirty="0">
-                        <a:latin typeface="Calibri" charset="0"/>
-                        <a:ea typeface="Calibri" charset="0"/>
-                        <a:cs typeface="Calibri" charset="0"/>
-                      </a:endParaRPr>
                     </a:p>
                   </a:txBody>
                   <a:tcPr anchor="ctr">
@@ -21716,7 +21757,7 @@
                 </a:tc>
                 <a:extLst>
                   <a:ext uri="{0D108BD9-81ED-4DB2-BD59-A6C34878D82A}">
-                    <a16:rowId xmlns:a16="http://schemas.microsoft.com/office/drawing/2014/main" val="10013"/>
+                    <a16:rowId xmlns:a16="http://schemas.microsoft.com/office/drawing/2014/main" val="3055060759"/>
                   </a:ext>
                 </a:extLst>
               </a:tr>
@@ -22749,6 +22790,30 @@
           </a:p>
         </p:txBody>
       </p:sp>
+      <p:pic>
+        <p:nvPicPr>
+          <p:cNvPr id="17" name="Picture 16" descr="rover_dev2_1.png"/>
+          <p:cNvPicPr>
+            <a:picLocks noChangeAspect="1"/>
+          </p:cNvPicPr>
+          <p:nvPr/>
+        </p:nvPicPr>
+        <p:blipFill>
+          <a:blip r:embed="rId3"/>
+          <a:stretch>
+            <a:fillRect/>
+          </a:stretch>
+        </p:blipFill>
+        <p:spPr>
+          <a:xfrm>
+            <a:off x="1292938" y="6400800"/>
+            <a:ext cx="5186524" cy="2834640"/>
+          </a:xfrm>
+          <a:prstGeom prst="rect">
+            <a:avLst/>
+          </a:prstGeom>
+        </p:spPr>
+      </p:pic>
     </p:spTree>
   </p:cSld>
   <p:clrMapOvr>
@@ -28084,6 +28149,30 @@
           </a:prstGeom>
         </p:spPr>
       </p:pic>
+      <p:pic>
+        <p:nvPicPr>
+          <p:cNvPr id="24" name="Picture 23" descr="ensamble_lateral_arms.png"/>
+          <p:cNvPicPr>
+            <a:picLocks noChangeAspect="1"/>
+          </p:cNvPicPr>
+          <p:nvPr/>
+        </p:nvPicPr>
+        <p:blipFill>
+          <a:blip r:embed="rId4"/>
+          <a:stretch>
+            <a:fillRect/>
+          </a:stretch>
+        </p:blipFill>
+        <p:spPr>
+          <a:xfrm>
+            <a:off x="2510028" y="7269480"/>
+            <a:ext cx="2752344" cy="1965960"/>
+          </a:xfrm>
+          <a:prstGeom prst="rect">
+            <a:avLst/>
+          </a:prstGeom>
+        </p:spPr>
+      </p:pic>
     </p:spTree>
   </p:cSld>
   <p:clrMapOvr>
@@ -31390,6 +31479,54 @@
           </a:p>
         </p:txBody>
       </p:sp>
+      <p:pic>
+        <p:nvPicPr>
+          <p:cNvPr id="21" name="Picture 20" descr="image.png"/>
+          <p:cNvPicPr>
+            <a:picLocks noChangeAspect="1"/>
+          </p:cNvPicPr>
+          <p:nvPr/>
+        </p:nvPicPr>
+        <p:blipFill>
+          <a:blip r:embed="rId3"/>
+          <a:stretch>
+            <a:fillRect/>
+          </a:stretch>
+        </p:blipFill>
+        <p:spPr>
+          <a:xfrm>
+            <a:off x="5151120" y="2286000"/>
+            <a:ext cx="1767840" cy="1325880"/>
+          </a:xfrm>
+          <a:prstGeom prst="rect">
+            <a:avLst/>
+          </a:prstGeom>
+        </p:spPr>
+      </p:pic>
+      <p:pic>
+        <p:nvPicPr>
+          <p:cNvPr id="22" name="Picture 21" descr="image.png"/>
+          <p:cNvPicPr>
+            <a:picLocks noChangeAspect="1"/>
+          </p:cNvPicPr>
+          <p:nvPr/>
+        </p:nvPicPr>
+        <p:blipFill>
+          <a:blip r:embed="rId3"/>
+          <a:stretch>
+            <a:fillRect/>
+          </a:stretch>
+        </p:blipFill>
+        <p:spPr>
+          <a:xfrm>
+            <a:off x="2301240" y="6858000"/>
+            <a:ext cx="3169920" cy="2377440"/>
+          </a:xfrm>
+          <a:prstGeom prst="rect">
+            <a:avLst/>
+          </a:prstGeom>
+        </p:spPr>
+      </p:pic>
     </p:spTree>
   </p:cSld>
   <p:clrMapOvr>

</xml_diff>

<commit_message>
Trim BOM to quoted items only, fix CSV format, remove stray lock file
- BOM/bom_rover.csv: comma-delimited (was semicolon, which silently
  breaks standard CSV parsers - likely why an external review flagged
  it as broken), UTF-8 without BOM mark, new Montaje column stating
  where each part physically mounts. Dropped every row that isn't
  actually quoted (Pendiente/WIP/Fijo placeholders) per instruction -
  the CSV now only lists the 24 items priced in Cotizacion S174842.
- README and journal pages 17/18 updated to match: no more references
  to a "Pendiente" list inside the BOM itself.
- Removed an accidentally-committed PowerPoint lock file
  (~$Librito_Rover...pptx) and added .gitignore for Office temp files.
</commit_message>
<xml_diff>
--- a/Journal/Librito_Rover x_x (CreacionSistemaMecanico) .pptx
+++ b/Journal/Librito_Rover x_x (CreacionSistemaMecanico) .pptx
@@ -17514,7 +17514,7 @@
                 </a:solidFill>
                 <a:latin typeface="Calibri"/>
               </a:rPr>
-              <a:t>Chassis hardware (round tube, acrylic lid, most of the bolts), the battery + charger, and the lab sensors are still on the "Pendiente" list in the BOM - this quote covers movilidad, chasis extrusion, filament, and the brain, but nothing has actually been ordered yet.</a:t>
+              <a:t>Chassis hardware (round tube, acrylic lid, most of the bolts), the battery + charger, and the lab sensors are not in bom_rover.csv yet - no real quote for them so far. This quote covers movilidad, chasis extrusion, filament, and the brain, but nothing has actually been ordered yet.</a:t>
             </a:r>
             <a:endParaRPr lang="en-US" sz="1000" dirty="0"/>
           </a:p>
@@ -18014,7 +18014,7 @@
                 <a:ea typeface="Calibri" pitchFamily="34" charset="-122"/>
                 <a:cs typeface="Calibri" pitchFamily="34" charset="-120"/>
               </a:rPr>
-              <a:t>Movilidad electronics, chassis extrusion, filament, and the brain are priced out in a real quote (bom_rover.csv, Cotizacion S174842) but nothing has been purchased yet. Still pending: round tube + steel axle for the differential, the acrylic/MDF lid, the battery + charger, and the lab module hardware (color sensor, pumps, syringe dispenser).</a:t>
+              <a:t>Movilidad electronics, chassis extrusion, filament, and the brain are priced out in a real quote (bom_rover.csv, Cotizacion S174842) but nothing has been purchased yet. Still needed, no quote yet: round tube + steel axle for the differential, the acrylic/MDF lid, the battery + charger, and the lab module hardware (color sensor, pumps, syringe dispenser).</a:t>
             </a:r>
             <a:endParaRPr lang="en-US" sz="1250" dirty="0"/>
           </a:p>
@@ -22964,7 +22964,7 @@
           <p:nvPr>
             <p:extLst>
               <p:ext uri="{D42A27DB-BD31-4B8C-83A1-F6EECF244321}">
-                <p14:modId xmlns:p14="http://schemas.microsoft.com/office/powerpoint/2010/main" val="1579011935"/>
+                <p14:modId xmlns:p14="http://schemas.microsoft.com/office/powerpoint/2010/main" val="1653401315"/>
               </p:ext>
             </p:extLst>
           </p:nvPr>
@@ -23552,7 +23552,7 @@
                           <a:ea typeface="Calibri" pitchFamily="34" charset="-122"/>
                           <a:cs typeface="Calibri" pitchFamily="34" charset="-120"/>
                         </a:rPr>
-                        <a:t>900 mm (turns out 1200 wasn't fixed)</a:t>
+                        <a:t>900 m</a:t>
                       </a:r>
                       <a:endParaRPr lang="en-US" sz="1200" dirty="0">
                         <a:latin typeface="Calibri" charset="0"/>

</xml_diff>